<commit_message>
Đồng bộ ảnh đại diện "Xem 3 phút" ở trang chủ sang tiếng Anh (#17)
Khối giới thiệu video ở trang chủ (khung_phim()) lấy ảnh đại diện từ
assets/slides/ch1/001.jpg — ảnh trang bìa của bộ slide Chương 1, không
liên quan gì tới tệp video. Bìa video Chương 1 đã đổi sang tiếng Anh ở
PR #14, nhưng ảnh đại diện này vẫn tiếng Việt vì là một tài sản khác,
xuất riêng từ slides/01-tong-quan-giao-tiep.pptx.

Sửa đúng ở nguồn: dịch 7 dòng chữ trên slide 1 của pptx sang tiếng Anh
(khớp đúng bản dịch đã dùng cho bìa video), rồi xuất lại đúng trang 1
bằng cùng cách scripts/xuat_slide.py vẫn dùng (soffice → PDF → pdftoppm
110dpi → JPEG 1280x720, quality 84). Không chạy xuat_slide.py nguyên bộ
vì hai lý do: script còn hardcode đường dẫn máy cũ (/workspace/comdraft)
chưa chạy được ở đây, và chạy nguyên bộ sẽ xuất lại cả 8 bộ slide trong
khi chỉ một trang của một bộ cần đổi. 18 trang còn lại của Chương 1 và
data/slides.js (số trang không đổi, vẫn 19) giữ nguyên.
</commit_message>
<xml_diff>
--- a/slides/01-tong-quan-giao-tiep.pptx
+++ b/slides/01-tong-quan-giao-tiep.pptx
@@ -3065,7 +3065,7 @@
                 <a:ea typeface="Calibri" pitchFamily="34" charset="-122"/>
                 <a:cs typeface="Calibri" pitchFamily="34" charset="-120"/>
               </a:rPr>
-              <a:t>CHƯƠNG 1</a:t>
+              <a:t>CHAPTER 1</a:t>
             </a:r>
             <a:endParaRPr lang="en-US" sz="1800" dirty="0"/>
           </a:p>
@@ -3128,7 +3128,7 @@
                 <a:ea typeface="Cambria" pitchFamily="34" charset="-122"/>
                 <a:cs typeface="Cambria" pitchFamily="34" charset="-120"/>
               </a:rPr>
-              <a:t>Tổng quan về giao tiếp</a:t>
+              <a:t>An overview of</a:t>
             </a:r>
             <a:endParaRPr lang="en-US" sz="3800" dirty="0"/>
           </a:p>
@@ -3145,7 +3145,7 @@
                 <a:ea typeface="Cambria" pitchFamily="34" charset="-122"/>
                 <a:cs typeface="Cambria" pitchFamily="34" charset="-120"/>
               </a:rPr>
-              <a:t>trong kinh doanh</a:t>
+              <a:t>business communication</a:t>
             </a:r>
             <a:endParaRPr lang="en-US" sz="3800" dirty="0"/>
           </a:p>
@@ -3184,7 +3184,7 @@
                 <a:ea typeface="Calibri" pitchFamily="34" charset="-122"/>
                 <a:cs typeface="Calibri" pitchFamily="34" charset="-120"/>
               </a:rPr>
-              <a:t>Nền móng của mọi kỹ năng nghề nghiệp: hiểu đúng về giao tiếp trước khi luyện kỹ năng.</a:t>
+              <a:t>The foundation of every professional skill: understand communication before you practice it.</a:t>
             </a:r>
             <a:endParaRPr lang="en-US" sz="1400" dirty="0"/>
           </a:p>
@@ -3223,7 +3223,7 @@
                 <a:ea typeface="Calibri" pitchFamily="34" charset="-122"/>
                 <a:cs typeface="Calibri" pitchFamily="34" charset="-120"/>
               </a:rPr>
-              <a:t>GV. Đỗ Thùy Hương</a:t>
+              <a:t>Lecturer Đỗ Thùy Hương</a:t>
             </a:r>
             <a:endParaRPr lang="en-US" sz="1500" dirty="0"/>
           </a:p>
@@ -3240,7 +3240,7 @@
                 <a:ea typeface="Calibri" pitchFamily="34" charset="-122"/>
                 <a:cs typeface="Calibri" pitchFamily="34" charset="-120"/>
               </a:rPr>
-              <a:t>EC1103 – Kỹ năng giao tiếp và soạn thảo văn bản (2:1)  •  Lớp 261b, HK1 năm học 2026 – 2027</a:t>
+              <a:t>EC1103 – Business Communication and Document Drafting (2:1)  •  Class 261b, Semester 1, AY 2026–2027</a:t>
             </a:r>
             <a:endParaRPr lang="en-US" sz="1500" dirty="0"/>
           </a:p>
@@ -3279,7 +3279,7 @@
                 <a:ea typeface="Calibri" pitchFamily="34" charset="-122"/>
                 <a:cs typeface="Calibri" pitchFamily="34" charset="-120"/>
               </a:rPr>
-              <a:t>© Đỗ Thùy Hương, 2026 — Bài giảng biên soạn cho lớp giảng dạy trực tiếp. Vui lòng ghi nguồn khi sử dụng.</a:t>
+              <a:t>© Đỗ Thùy Hương, 2026 — Course material prepared for in-person teaching. Please credit the source when reused.</a:t>
             </a:r>
             <a:endParaRPr lang="en-US" sz="900" dirty="0"/>
           </a:p>
@@ -3318,6 +3318,1413 @@
 </file>
 
 <file path=ppt/slides/slide10.xml><?xml version="1.0" encoding="utf-8"?>
+<p:sld xmlns:a="http://schemas.openxmlformats.org/drawingml/2006/main" xmlns:r="http://schemas.openxmlformats.org/officeDocument/2006/relationships" xmlns:p="http://schemas.openxmlformats.org/presentationml/2006/main">
+  <p:cSld name="Slide 9">
+    <p:bg>
+      <p:bgPr>
+        <a:solidFill>
+          <a:srgbClr val="FDFBF8"/>
+        </a:solidFill>
+      </p:bgPr>
+    </p:bg>
+    <p:spTree>
+      <p:nvGrpSpPr>
+        <p:cNvPr id="1" name=""/>
+        <p:cNvGrpSpPr/>
+        <p:nvPr/>
+      </p:nvGrpSpPr>
+      <p:grpSpPr>
+        <a:xfrm>
+          <a:off x="0" y="0"/>
+          <a:ext cx="0" cy="0"/>
+          <a:chOff x="0" y="0"/>
+          <a:chExt cx="0" cy="0"/>
+        </a:xfrm>
+      </p:grpSpPr>
+      <p:pic>
+        <p:nvPicPr>
+          <p:cNvPr id="2" name="Image 0" descr="assets/logo_tron.png">    </p:cNvPr>
+          <p:cNvPicPr>
+            <a:picLocks noChangeAspect="1"/>
+          </p:cNvPicPr>
+          <p:nvPr/>
+        </p:nvPicPr>
+        <p:blipFill>
+          <a:blip r:embed="rId1"/>
+          <a:stretch>
+            <a:fillRect/>
+          </a:stretch>
+        </p:blipFill>
+        <p:spPr>
+          <a:xfrm>
+            <a:off x="411480" y="6327648"/>
+            <a:ext cx="384048" cy="384048"/>
+          </a:xfrm>
+          <a:prstGeom prst="rect">
+            <a:avLst/>
+          </a:prstGeom>
+        </p:spPr>
+      </p:pic>
+      <p:sp>
+        <p:nvSpPr>
+          <p:cNvPr id="3" name="Text 0"/>
+          <p:cNvSpPr/>
+          <p:nvPr/>
+        </p:nvSpPr>
+        <p:spPr>
+          <a:xfrm>
+            <a:off x="868680" y="6355080"/>
+            <a:ext cx="7498080" cy="310896"/>
+          </a:xfrm>
+          <a:prstGeom prst="rect">
+            <a:avLst/>
+          </a:prstGeom>
+          <a:noFill/>
+          <a:ln/>
+        </p:spPr>
+        <p:txBody>
+          <a:bodyPr wrap="square" lIns="0" tIns="0" rIns="0" bIns="0" rtlCol="0" anchor="ctr"/>
+          <a:lstStyle/>
+          <a:p>
+            <a:pPr indent="0" marL="0">
+              <a:buNone/>
+            </a:pPr>
+            <a:r>
+              <a:rPr lang="en-US" sz="900" dirty="0">
+                <a:solidFill>
+                  <a:srgbClr val="8A7A76"/>
+                </a:solidFill>
+                <a:latin typeface="Calibri" pitchFamily="34" charset="0"/>
+                <a:ea typeface="Calibri" pitchFamily="34" charset="-122"/>
+                <a:cs typeface="Calibri" pitchFamily="34" charset="-120"/>
+              </a:rPr>
+              <a:t>Je m'appelle Huong  •  GV. Đỗ Thùy Hương  •  EC1103</a:t>
+            </a:r>
+            <a:endParaRPr lang="en-US" sz="900" dirty="0"/>
+          </a:p>
+        </p:txBody>
+      </p:sp>
+      <p:sp>
+        <p:nvSpPr>
+          <p:cNvPr id="4" name="Text 1"/>
+          <p:cNvSpPr/>
+          <p:nvPr/>
+        </p:nvSpPr>
+        <p:spPr>
+          <a:xfrm>
+            <a:off x="8503920" y="6355080"/>
+            <a:ext cx="2743200" cy="310896"/>
+          </a:xfrm>
+          <a:prstGeom prst="rect">
+            <a:avLst/>
+          </a:prstGeom>
+          <a:noFill/>
+          <a:ln/>
+        </p:spPr>
+        <p:txBody>
+          <a:bodyPr wrap="square" lIns="0" tIns="0" rIns="0" bIns="0" rtlCol="0" anchor="ctr"/>
+          <a:lstStyle/>
+          <a:p>
+            <a:pPr algn="r" indent="0" marL="0">
+              <a:buNone/>
+            </a:pPr>
+            <a:r>
+              <a:rPr lang="en-US" sz="900" dirty="0">
+                <a:solidFill>
+                  <a:srgbClr val="8A7A76"/>
+                </a:solidFill>
+                <a:latin typeface="Calibri" pitchFamily="34" charset="0"/>
+                <a:ea typeface="Calibri" pitchFamily="34" charset="-122"/>
+                <a:cs typeface="Calibri" pitchFamily="34" charset="-120"/>
+              </a:rPr>
+              <a:t>Chương 1</a:t>
+            </a:r>
+            <a:endParaRPr lang="en-US" sz="900" dirty="0"/>
+          </a:p>
+        </p:txBody>
+      </p:sp>
+      <p:sp>
+        <p:nvSpPr>
+          <p:cNvPr id="5" name="Shape 2"/>
+          <p:cNvSpPr/>
+          <p:nvPr/>
+        </p:nvSpPr>
+        <p:spPr>
+          <a:xfrm>
+            <a:off x="11430000" y="6327648"/>
+            <a:ext cx="365760" cy="365760"/>
+          </a:xfrm>
+          <a:prstGeom prst="ellipse">
+            <a:avLst/>
+          </a:prstGeom>
+          <a:solidFill>
+            <a:srgbClr val="DC756A"/>
+          </a:solidFill>
+          <a:ln/>
+        </p:spPr>
+        <p:txBody>
+          <a:bodyPr/>
+          <a:p/>
+        </p:txBody>
+      </p:sp>
+      <p:sp>
+        <p:nvSpPr>
+          <p:cNvPr id="6" name="Text 3"/>
+          <p:cNvSpPr/>
+          <p:nvPr/>
+        </p:nvSpPr>
+        <p:spPr>
+          <a:xfrm>
+            <a:off x="11430000" y="6327648"/>
+            <a:ext cx="365760" cy="365760"/>
+          </a:xfrm>
+          <a:prstGeom prst="rect">
+            <a:avLst/>
+          </a:prstGeom>
+          <a:noFill/>
+          <a:ln/>
+        </p:spPr>
+        <p:txBody>
+          <a:bodyPr wrap="square" lIns="0" tIns="0" rIns="0" bIns="0" rtlCol="0" anchor="ctr"/>
+          <a:lstStyle/>
+          <a:p>
+            <a:pPr algn="ctr" indent="0" marL="0">
+              <a:buNone/>
+            </a:pPr>
+            <a:r>
+              <a:rPr lang="en-US" sz="1000" b="1" dirty="0">
+                <a:solidFill>
+                  <a:srgbClr val="FFFFFF"/>
+                </a:solidFill>
+                <a:latin typeface="Calibri" pitchFamily="34" charset="0"/>
+                <a:ea typeface="Calibri" pitchFamily="34" charset="-122"/>
+                <a:cs typeface="Calibri" pitchFamily="34" charset="-120"/>
+              </a:rPr>
+              <a:t>9</a:t>
+            </a:r>
+            <a:endParaRPr lang="en-US" sz="1000" dirty="0"/>
+          </a:p>
+        </p:txBody>
+      </p:sp>
+      <p:sp>
+        <p:nvSpPr>
+          <p:cNvPr id="7" name="Text 4"/>
+          <p:cNvSpPr/>
+          <p:nvPr/>
+        </p:nvSpPr>
+        <p:spPr>
+          <a:xfrm>
+            <a:off x="502920" y="310896"/>
+            <a:ext cx="11155680" cy="274320"/>
+          </a:xfrm>
+          <a:prstGeom prst="rect">
+            <a:avLst/>
+          </a:prstGeom>
+          <a:noFill/>
+          <a:ln/>
+        </p:spPr>
+        <p:txBody>
+          <a:bodyPr wrap="square" lIns="0" tIns="0" rIns="0" bIns="0" rtlCol="0" anchor="ctr"/>
+          <a:lstStyle/>
+          <a:p>
+            <a:pPr indent="0" marL="0">
+              <a:buNone/>
+            </a:pPr>
+            <a:r>
+              <a:rPr lang="en-US" sz="1100" b="1" spc="300" kern="0" dirty="0">
+                <a:solidFill>
+                  <a:srgbClr val="DC756A"/>
+                </a:solidFill>
+                <a:latin typeface="Calibri" pitchFamily="34" charset="0"/>
+                <a:ea typeface="Calibri" pitchFamily="34" charset="-122"/>
+                <a:cs typeface="Calibri" pitchFamily="34" charset="-120"/>
+              </a:rPr>
+              <a:t>1.2</a:t>
+            </a:r>
+            <a:endParaRPr lang="en-US" sz="1100" dirty="0"/>
+          </a:p>
+        </p:txBody>
+      </p:sp>
+      <p:sp>
+        <p:nvSpPr>
+          <p:cNvPr id="8" name="Text 5"/>
+          <p:cNvSpPr/>
+          <p:nvPr/>
+        </p:nvSpPr>
+        <p:spPr>
+          <a:xfrm>
+            <a:off x="502920" y="576072"/>
+            <a:ext cx="11155680" cy="713232"/>
+          </a:xfrm>
+          <a:prstGeom prst="rect">
+            <a:avLst/>
+          </a:prstGeom>
+          <a:noFill/>
+          <a:ln/>
+        </p:spPr>
+        <p:txBody>
+          <a:bodyPr wrap="square" lIns="0" tIns="0" rIns="0" bIns="0" rtlCol="0" anchor="ctr"/>
+          <a:lstStyle/>
+          <a:p>
+            <a:pPr indent="0" marL="0">
+              <a:buNone/>
+            </a:pPr>
+            <a:r>
+              <a:rPr lang="en-US" sz="2700" b="1" dirty="0">
+                <a:solidFill>
+                  <a:srgbClr val="AC4D33"/>
+                </a:solidFill>
+                <a:latin typeface="Cambria" pitchFamily="34" charset="0"/>
+                <a:ea typeface="Cambria" pitchFamily="34" charset="-122"/>
+                <a:cs typeface="Cambria" pitchFamily="34" charset="-120"/>
+              </a:rPr>
+              <a:t>Phương tiện giao tiếp: phi ngôn ngữ</a:t>
+            </a:r>
+            <a:endParaRPr lang="en-US" sz="2700" dirty="0"/>
+          </a:p>
+        </p:txBody>
+      </p:sp>
+      <p:sp>
+        <p:nvSpPr>
+          <p:cNvPr id="9" name="Shape 6"/>
+          <p:cNvSpPr/>
+          <p:nvPr/>
+        </p:nvSpPr>
+        <p:spPr>
+          <a:xfrm>
+            <a:off x="502920" y="1600200"/>
+            <a:ext cx="5509260" cy="1280160"/>
+          </a:xfrm>
+          <a:prstGeom prst="roundRect">
+            <a:avLst>
+              <a:gd name="adj" fmla="val 6429"/>
+            </a:avLst>
+          </a:prstGeom>
+          <a:solidFill>
+            <a:srgbClr val="FDF1EF"/>
+          </a:solidFill>
+          <a:ln w="15875">
+            <a:solidFill>
+              <a:srgbClr val="FBCEC9"/>
+            </a:solidFill>
+            <a:prstDash val="solid"/>
+          </a:ln>
+        </p:spPr>
+        <p:txBody>
+          <a:bodyPr/>
+          <a:p/>
+        </p:txBody>
+      </p:sp>
+      <p:sp>
+        <p:nvSpPr>
+          <p:cNvPr id="10" name="Text 7"/>
+          <p:cNvSpPr/>
+          <p:nvPr/>
+        </p:nvSpPr>
+        <p:spPr>
+          <a:xfrm>
+            <a:off x="722376" y="1673352"/>
+            <a:ext cx="5070348" cy="1133856"/>
+          </a:xfrm>
+          <a:prstGeom prst="rect">
+            <a:avLst/>
+          </a:prstGeom>
+          <a:noFill/>
+          <a:ln/>
+        </p:spPr>
+        <p:txBody>
+          <a:bodyPr wrap="square" lIns="0" tIns="0" rIns="0" bIns="0" rtlCol="0" anchor="ctr"/>
+          <a:lstStyle/>
+          <a:p>
+            <a:pPr indent="0" marL="0">
+              <a:buNone/>
+            </a:pPr>
+            <a:r>
+              <a:rPr lang="en-US" sz="1700" b="1" dirty="0">
+                <a:solidFill>
+                  <a:srgbClr val="AC4D33"/>
+                </a:solidFill>
+                <a:latin typeface="Calibri" pitchFamily="34" charset="0"/>
+                <a:ea typeface="Calibri" pitchFamily="34" charset="-122"/>
+                <a:cs typeface="Calibri" pitchFamily="34" charset="-120"/>
+              </a:rPr>
+              <a:t>Ánh mắt – nét mặt</a:t>
+            </a:r>
+            <a:endParaRPr lang="en-US" sz="1700" dirty="0"/>
+          </a:p>
+          <a:p>
+            <a:pPr indent="0" marL="0">
+              <a:buNone/>
+            </a:pPr>
+            <a:r>
+              <a:rPr lang="en-US" sz="1400" dirty="0">
+                <a:solidFill>
+                  <a:srgbClr val="3A2B28"/>
+                </a:solidFill>
+                <a:latin typeface="Calibri" pitchFamily="34" charset="0"/>
+                <a:ea typeface="Calibri" pitchFamily="34" charset="-122"/>
+                <a:cs typeface="Calibri" pitchFamily="34" charset="-120"/>
+              </a:rPr>
+              <a:t>Kênh biểu cảm mạnh nhất</a:t>
+            </a:r>
+            <a:endParaRPr lang="en-US" sz="1700" dirty="0"/>
+          </a:p>
+        </p:txBody>
+      </p:sp>
+      <p:sp>
+        <p:nvSpPr>
+          <p:cNvPr id="11" name="Shape 8"/>
+          <p:cNvSpPr/>
+          <p:nvPr/>
+        </p:nvSpPr>
+        <p:spPr>
+          <a:xfrm>
+            <a:off x="6195060" y="1600200"/>
+            <a:ext cx="5509260" cy="1280160"/>
+          </a:xfrm>
+          <a:prstGeom prst="roundRect">
+            <a:avLst>
+              <a:gd name="adj" fmla="val 6429"/>
+            </a:avLst>
+          </a:prstGeom>
+          <a:solidFill>
+            <a:srgbClr val="FDF1EF"/>
+          </a:solidFill>
+          <a:ln w="15875">
+            <a:solidFill>
+              <a:srgbClr val="FBCEC9"/>
+            </a:solidFill>
+            <a:prstDash val="solid"/>
+          </a:ln>
+        </p:spPr>
+        <p:txBody>
+          <a:bodyPr/>
+          <a:p/>
+        </p:txBody>
+      </p:sp>
+      <p:sp>
+        <p:nvSpPr>
+          <p:cNvPr id="12" name="Text 9"/>
+          <p:cNvSpPr/>
+          <p:nvPr/>
+        </p:nvSpPr>
+        <p:spPr>
+          <a:xfrm>
+            <a:off x="6414516" y="1673352"/>
+            <a:ext cx="5070348" cy="1133856"/>
+          </a:xfrm>
+          <a:prstGeom prst="rect">
+            <a:avLst/>
+          </a:prstGeom>
+          <a:noFill/>
+          <a:ln/>
+        </p:spPr>
+        <p:txBody>
+          <a:bodyPr wrap="square" lIns="0" tIns="0" rIns="0" bIns="0" rtlCol="0" anchor="ctr"/>
+          <a:lstStyle/>
+          <a:p>
+            <a:pPr indent="0" marL="0">
+              <a:buNone/>
+            </a:pPr>
+            <a:r>
+              <a:rPr lang="en-US" sz="1700" b="1" dirty="0">
+                <a:solidFill>
+                  <a:srgbClr val="AC4D33"/>
+                </a:solidFill>
+                <a:latin typeface="Calibri" pitchFamily="34" charset="0"/>
+                <a:ea typeface="Calibri" pitchFamily="34" charset="-122"/>
+                <a:cs typeface="Calibri" pitchFamily="34" charset="-120"/>
+              </a:rPr>
+              <a:t>Cử chỉ – tư thế</a:t>
+            </a:r>
+            <a:endParaRPr lang="en-US" sz="1700" dirty="0"/>
+          </a:p>
+          <a:p>
+            <a:pPr indent="0" marL="0">
+              <a:buNone/>
+            </a:pPr>
+            <a:r>
+              <a:rPr lang="en-US" sz="1400" dirty="0">
+                <a:solidFill>
+                  <a:srgbClr val="3A2B28"/>
+                </a:solidFill>
+                <a:latin typeface="Calibri" pitchFamily="34" charset="0"/>
+                <a:ea typeface="Calibri" pitchFamily="34" charset="-122"/>
+                <a:cs typeface="Calibri" pitchFamily="34" charset="-120"/>
+              </a:rPr>
+              <a:t>Thẳng và cởi mở tạo thiện cảm</a:t>
+            </a:r>
+            <a:endParaRPr lang="en-US" sz="1700" dirty="0"/>
+          </a:p>
+        </p:txBody>
+      </p:sp>
+      <p:sp>
+        <p:nvSpPr>
+          <p:cNvPr id="13" name="Shape 10"/>
+          <p:cNvSpPr/>
+          <p:nvPr/>
+        </p:nvSpPr>
+        <p:spPr>
+          <a:xfrm>
+            <a:off x="502920" y="3063240"/>
+            <a:ext cx="5509260" cy="1280160"/>
+          </a:xfrm>
+          <a:prstGeom prst="roundRect">
+            <a:avLst>
+              <a:gd name="adj" fmla="val 6429"/>
+            </a:avLst>
+          </a:prstGeom>
+          <a:solidFill>
+            <a:srgbClr val="FDF1EF"/>
+          </a:solidFill>
+          <a:ln w="15875">
+            <a:solidFill>
+              <a:srgbClr val="FBCEC9"/>
+            </a:solidFill>
+            <a:prstDash val="solid"/>
+          </a:ln>
+        </p:spPr>
+        <p:txBody>
+          <a:bodyPr/>
+          <a:p/>
+        </p:txBody>
+      </p:sp>
+      <p:sp>
+        <p:nvSpPr>
+          <p:cNvPr id="14" name="Text 11"/>
+          <p:cNvSpPr/>
+          <p:nvPr/>
+        </p:nvSpPr>
+        <p:spPr>
+          <a:xfrm>
+            <a:off x="722376" y="3136392"/>
+            <a:ext cx="5070348" cy="1133856"/>
+          </a:xfrm>
+          <a:prstGeom prst="rect">
+            <a:avLst/>
+          </a:prstGeom>
+          <a:noFill/>
+          <a:ln/>
+        </p:spPr>
+        <p:txBody>
+          <a:bodyPr wrap="square" lIns="0" tIns="0" rIns="0" bIns="0" rtlCol="0" anchor="ctr"/>
+          <a:lstStyle/>
+          <a:p>
+            <a:pPr indent="0" marL="0">
+              <a:buNone/>
+            </a:pPr>
+            <a:r>
+              <a:rPr lang="en-US" sz="1700" b="1" dirty="0">
+                <a:solidFill>
+                  <a:srgbClr val="AC4D33"/>
+                </a:solidFill>
+                <a:latin typeface="Calibri" pitchFamily="34" charset="0"/>
+                <a:ea typeface="Calibri" pitchFamily="34" charset="-122"/>
+                <a:cs typeface="Calibri" pitchFamily="34" charset="-120"/>
+              </a:rPr>
+              <a:t>Khoảng cách</a:t>
+            </a:r>
+            <a:endParaRPr lang="en-US" sz="1700" dirty="0"/>
+          </a:p>
+          <a:p>
+            <a:pPr indent="0" marL="0">
+              <a:buNone/>
+            </a:pPr>
+            <a:r>
+              <a:rPr lang="en-US" sz="1400" dirty="0">
+                <a:solidFill>
+                  <a:srgbClr val="3A2B28"/>
+                </a:solidFill>
+                <a:latin typeface="Calibri" pitchFamily="34" charset="0"/>
+                <a:ea typeface="Calibri" pitchFamily="34" charset="-122"/>
+                <a:cs typeface="Calibri" pitchFamily="34" charset="-120"/>
+              </a:rPr>
+              <a:t>Thân mật · cá nhân · xã giao · công cộng</a:t>
+            </a:r>
+            <a:endParaRPr lang="en-US" sz="1700" dirty="0"/>
+          </a:p>
+        </p:txBody>
+      </p:sp>
+      <p:sp>
+        <p:nvSpPr>
+          <p:cNvPr id="15" name="Shape 12"/>
+          <p:cNvSpPr/>
+          <p:nvPr/>
+        </p:nvSpPr>
+        <p:spPr>
+          <a:xfrm>
+            <a:off x="6195060" y="3063240"/>
+            <a:ext cx="5509260" cy="1280160"/>
+          </a:xfrm>
+          <a:prstGeom prst="roundRect">
+            <a:avLst>
+              <a:gd name="adj" fmla="val 6429"/>
+            </a:avLst>
+          </a:prstGeom>
+          <a:solidFill>
+            <a:srgbClr val="FDF1EF"/>
+          </a:solidFill>
+          <a:ln w="15875">
+            <a:solidFill>
+              <a:srgbClr val="FBCEC9"/>
+            </a:solidFill>
+            <a:prstDash val="solid"/>
+          </a:ln>
+        </p:spPr>
+        <p:txBody>
+          <a:bodyPr/>
+          <a:p/>
+        </p:txBody>
+      </p:sp>
+      <p:sp>
+        <p:nvSpPr>
+          <p:cNvPr id="16" name="Text 13"/>
+          <p:cNvSpPr/>
+          <p:nvPr/>
+        </p:nvSpPr>
+        <p:spPr>
+          <a:xfrm>
+            <a:off x="6414516" y="3136392"/>
+            <a:ext cx="5070348" cy="1133856"/>
+          </a:xfrm>
+          <a:prstGeom prst="rect">
+            <a:avLst/>
+          </a:prstGeom>
+          <a:noFill/>
+          <a:ln/>
+        </p:spPr>
+        <p:txBody>
+          <a:bodyPr wrap="square" lIns="0" tIns="0" rIns="0" bIns="0" rtlCol="0" anchor="ctr"/>
+          <a:lstStyle/>
+          <a:p>
+            <a:pPr indent="0" marL="0">
+              <a:buNone/>
+            </a:pPr>
+            <a:r>
+              <a:rPr lang="en-US" sz="1700" b="1" dirty="0">
+                <a:solidFill>
+                  <a:srgbClr val="AC4D33"/>
+                </a:solidFill>
+                <a:latin typeface="Calibri" pitchFamily="34" charset="0"/>
+                <a:ea typeface="Calibri" pitchFamily="34" charset="-122"/>
+                <a:cs typeface="Calibri" pitchFamily="34" charset="-120"/>
+              </a:rPr>
+              <a:t>Trang phục – giọng – giờ giấc</a:t>
+            </a:r>
+            <a:endParaRPr lang="en-US" sz="1700" dirty="0"/>
+          </a:p>
+          <a:p>
+            <a:pPr indent="0" marL="0">
+              <a:buNone/>
+            </a:pPr>
+            <a:r>
+              <a:rPr lang="en-US" sz="1400" dirty="0">
+                <a:solidFill>
+                  <a:srgbClr val="3A2B28"/>
+                </a:solidFill>
+                <a:latin typeface="Calibri" pitchFamily="34" charset="0"/>
+                <a:ea typeface="Calibri" pitchFamily="34" charset="-122"/>
+                <a:cs typeface="Calibri" pitchFamily="34" charset="-120"/>
+              </a:rPr>
+              <a:t>Đúng giờ cũng là một thông điệp</a:t>
+            </a:r>
+            <a:endParaRPr lang="en-US" sz="1700" dirty="0"/>
+          </a:p>
+        </p:txBody>
+      </p:sp>
+      <p:sp>
+        <p:nvSpPr>
+          <p:cNvPr id="17" name="Text 14"/>
+          <p:cNvSpPr/>
+          <p:nvPr/>
+        </p:nvSpPr>
+        <p:spPr>
+          <a:xfrm>
+            <a:off x="777240" y="4617720"/>
+            <a:ext cx="3566160" cy="868680"/>
+          </a:xfrm>
+          <a:prstGeom prst="rect">
+            <a:avLst/>
+          </a:prstGeom>
+          <a:noFill/>
+          <a:ln/>
+        </p:spPr>
+        <p:txBody>
+          <a:bodyPr wrap="square" lIns="0" tIns="0" rIns="0" bIns="0" rtlCol="0" anchor="ctr"/>
+          <a:lstStyle/>
+          <a:p>
+            <a:pPr algn="ctr" indent="0" marL="0">
+              <a:buNone/>
+            </a:pPr>
+            <a:r>
+              <a:rPr lang="en-US" sz="4400" b="1" dirty="0">
+                <a:solidFill>
+                  <a:srgbClr val="DC756A"/>
+                </a:solidFill>
+                <a:latin typeface="Cambria" pitchFamily="34" charset="0"/>
+                <a:ea typeface="Cambria" pitchFamily="34" charset="-122"/>
+                <a:cs typeface="Cambria" pitchFamily="34" charset="-120"/>
+              </a:rPr>
+              <a:t>7%</a:t>
+            </a:r>
+            <a:endParaRPr lang="en-US" sz="4400" dirty="0"/>
+          </a:p>
+        </p:txBody>
+      </p:sp>
+      <p:sp>
+        <p:nvSpPr>
+          <p:cNvPr id="18" name="Text 15"/>
+          <p:cNvSpPr/>
+          <p:nvPr/>
+        </p:nvSpPr>
+        <p:spPr>
+          <a:xfrm>
+            <a:off x="777240" y="5486400"/>
+            <a:ext cx="3566160" cy="365760"/>
+          </a:xfrm>
+          <a:prstGeom prst="rect">
+            <a:avLst/>
+          </a:prstGeom>
+          <a:noFill/>
+          <a:ln/>
+        </p:spPr>
+        <p:txBody>
+          <a:bodyPr wrap="square" lIns="0" tIns="0" rIns="0" bIns="0" rtlCol="0" anchor="ctr"/>
+          <a:lstStyle/>
+          <a:p>
+            <a:pPr algn="ctr" indent="0" marL="0">
+              <a:buNone/>
+            </a:pPr>
+            <a:r>
+              <a:rPr lang="en-US" sz="1300" b="1" spc="200" kern="0" dirty="0">
+                <a:solidFill>
+                  <a:srgbClr val="8A7A76"/>
+                </a:solidFill>
+                <a:latin typeface="Calibri" pitchFamily="34" charset="0"/>
+                <a:ea typeface="Calibri" pitchFamily="34" charset="-122"/>
+                <a:cs typeface="Calibri" pitchFamily="34" charset="-120"/>
+              </a:rPr>
+              <a:t>TỪ NGỮ</a:t>
+            </a:r>
+            <a:endParaRPr lang="en-US" sz="1300" dirty="0"/>
+          </a:p>
+        </p:txBody>
+      </p:sp>
+      <p:sp>
+        <p:nvSpPr>
+          <p:cNvPr id="19" name="Text 16"/>
+          <p:cNvSpPr/>
+          <p:nvPr/>
+        </p:nvSpPr>
+        <p:spPr>
+          <a:xfrm>
+            <a:off x="4754880" y="4617720"/>
+            <a:ext cx="3566160" cy="868680"/>
+          </a:xfrm>
+          <a:prstGeom prst="rect">
+            <a:avLst/>
+          </a:prstGeom>
+          <a:noFill/>
+          <a:ln/>
+        </p:spPr>
+        <p:txBody>
+          <a:bodyPr wrap="square" lIns="0" tIns="0" rIns="0" bIns="0" rtlCol="0" anchor="ctr"/>
+          <a:lstStyle/>
+          <a:p>
+            <a:pPr algn="ctr" indent="0" marL="0">
+              <a:buNone/>
+            </a:pPr>
+            <a:r>
+              <a:rPr lang="en-US" sz="4400" b="1" dirty="0">
+                <a:solidFill>
+                  <a:srgbClr val="DC756A"/>
+                </a:solidFill>
+                <a:latin typeface="Cambria" pitchFamily="34" charset="0"/>
+                <a:ea typeface="Cambria" pitchFamily="34" charset="-122"/>
+                <a:cs typeface="Cambria" pitchFamily="34" charset="-120"/>
+              </a:rPr>
+              <a:t>38%</a:t>
+            </a:r>
+            <a:endParaRPr lang="en-US" sz="4400" dirty="0"/>
+          </a:p>
+        </p:txBody>
+      </p:sp>
+      <p:sp>
+        <p:nvSpPr>
+          <p:cNvPr id="20" name="Text 17"/>
+          <p:cNvSpPr/>
+          <p:nvPr/>
+        </p:nvSpPr>
+        <p:spPr>
+          <a:xfrm>
+            <a:off x="4754880" y="5486400"/>
+            <a:ext cx="3566160" cy="365760"/>
+          </a:xfrm>
+          <a:prstGeom prst="rect">
+            <a:avLst/>
+          </a:prstGeom>
+          <a:noFill/>
+          <a:ln/>
+        </p:spPr>
+        <p:txBody>
+          <a:bodyPr wrap="square" lIns="0" tIns="0" rIns="0" bIns="0" rtlCol="0" anchor="ctr"/>
+          <a:lstStyle/>
+          <a:p>
+            <a:pPr algn="ctr" indent="0" marL="0">
+              <a:buNone/>
+            </a:pPr>
+            <a:r>
+              <a:rPr lang="en-US" sz="1300" b="1" spc="200" kern="0" dirty="0">
+                <a:solidFill>
+                  <a:srgbClr val="8A7A76"/>
+                </a:solidFill>
+                <a:latin typeface="Calibri" pitchFamily="34" charset="0"/>
+                <a:ea typeface="Calibri" pitchFamily="34" charset="-122"/>
+                <a:cs typeface="Calibri" pitchFamily="34" charset="-120"/>
+              </a:rPr>
+              <a:t>GIỌNG NÓI</a:t>
+            </a:r>
+            <a:endParaRPr lang="en-US" sz="1300" dirty="0"/>
+          </a:p>
+        </p:txBody>
+      </p:sp>
+      <p:sp>
+        <p:nvSpPr>
+          <p:cNvPr id="21" name="Text 18"/>
+          <p:cNvSpPr/>
+          <p:nvPr/>
+        </p:nvSpPr>
+        <p:spPr>
+          <a:xfrm>
+            <a:off x="8732520" y="4617720"/>
+            <a:ext cx="3566160" cy="868680"/>
+          </a:xfrm>
+          <a:prstGeom prst="rect">
+            <a:avLst/>
+          </a:prstGeom>
+          <a:noFill/>
+          <a:ln/>
+        </p:spPr>
+        <p:txBody>
+          <a:bodyPr wrap="square" lIns="0" tIns="0" rIns="0" bIns="0" rtlCol="0" anchor="ctr"/>
+          <a:lstStyle/>
+          <a:p>
+            <a:pPr algn="ctr" indent="0" marL="0">
+              <a:buNone/>
+            </a:pPr>
+            <a:r>
+              <a:rPr lang="en-US" sz="4400" b="1" dirty="0">
+                <a:solidFill>
+                  <a:srgbClr val="AC4D33"/>
+                </a:solidFill>
+                <a:latin typeface="Cambria" pitchFamily="34" charset="0"/>
+                <a:ea typeface="Cambria" pitchFamily="34" charset="-122"/>
+                <a:cs typeface="Cambria" pitchFamily="34" charset="-120"/>
+              </a:rPr>
+              <a:t>55%</a:t>
+            </a:r>
+            <a:endParaRPr lang="en-US" sz="4400" dirty="0"/>
+          </a:p>
+        </p:txBody>
+      </p:sp>
+      <p:sp>
+        <p:nvSpPr>
+          <p:cNvPr id="22" name="Text 19"/>
+          <p:cNvSpPr/>
+          <p:nvPr/>
+        </p:nvSpPr>
+        <p:spPr>
+          <a:xfrm>
+            <a:off x="8732520" y="5486400"/>
+            <a:ext cx="3566160" cy="365760"/>
+          </a:xfrm>
+          <a:prstGeom prst="rect">
+            <a:avLst/>
+          </a:prstGeom>
+          <a:noFill/>
+          <a:ln/>
+        </p:spPr>
+        <p:txBody>
+          <a:bodyPr wrap="square" lIns="0" tIns="0" rIns="0" bIns="0" rtlCol="0" anchor="ctr"/>
+          <a:lstStyle/>
+          <a:p>
+            <a:pPr algn="ctr" indent="0" marL="0">
+              <a:buNone/>
+            </a:pPr>
+            <a:r>
+              <a:rPr lang="en-US" sz="1300" b="1" spc="200" kern="0" dirty="0">
+                <a:solidFill>
+                  <a:srgbClr val="8A7A76"/>
+                </a:solidFill>
+                <a:latin typeface="Calibri" pitchFamily="34" charset="0"/>
+                <a:ea typeface="Calibri" pitchFamily="34" charset="-122"/>
+                <a:cs typeface="Calibri" pitchFamily="34" charset="-120"/>
+              </a:rPr>
+              <a:t>CƠ THỂ</a:t>
+            </a:r>
+            <a:endParaRPr lang="en-US" sz="1300" dirty="0"/>
+          </a:p>
+        </p:txBody>
+      </p:sp>
+      <p:sp>
+        <p:nvSpPr>
+          <p:cNvPr id="23" name="Text 20"/>
+          <p:cNvSpPr/>
+          <p:nvPr/>
+        </p:nvSpPr>
+        <p:spPr>
+          <a:xfrm>
+            <a:off x="502920" y="5943600"/>
+            <a:ext cx="11201400" cy="365760"/>
+          </a:xfrm>
+          <a:prstGeom prst="rect">
+            <a:avLst/>
+          </a:prstGeom>
+          <a:noFill/>
+          <a:ln/>
+        </p:spPr>
+        <p:txBody>
+          <a:bodyPr wrap="square" lIns="0" tIns="0" rIns="0" bIns="0" rtlCol="0" anchor="ctr"/>
+          <a:lstStyle/>
+          <a:p>
+            <a:pPr algn="ctr" indent="0" marL="0">
+              <a:buNone/>
+            </a:pPr>
+            <a:r>
+              <a:rPr lang="en-US" sz="1200" i="1" dirty="0">
+                <a:solidFill>
+                  <a:srgbClr val="8A7A76"/>
+                </a:solidFill>
+                <a:latin typeface="Calibri" pitchFamily="34" charset="0"/>
+                <a:ea typeface="Calibri" pitchFamily="34" charset="-122"/>
+                <a:cs typeface="Calibri" pitchFamily="34" charset="-120"/>
+              </a:rPr>
+              <a:t>Mehrabian — với thông điệp cảm xúc</a:t>
+            </a:r>
+            <a:endParaRPr lang="en-US" sz="1200" dirty="0"/>
+          </a:p>
+        </p:txBody>
+      </p:sp>
+    </p:spTree>
+  </p:cSld>
+  <p:clrMapOvr>
+    <a:masterClrMapping/>
+  </p:clrMapOvr>
+</p:sld>
+</file>
+
+<file path=ppt/slides/slide11.xml><?xml version="1.0" encoding="utf-8"?>
+<p:sld xmlns:a="http://schemas.openxmlformats.org/drawingml/2006/main" xmlns:p="http://schemas.openxmlformats.org/presentationml/2006/main" xmlns:r="http://schemas.openxmlformats.org/officeDocument/2006/relationships">
+  <p:cSld>
+    <p:spTree>
+      <p:nvGrpSpPr>
+        <p:cNvPr id="1" name=""/>
+        <p:cNvGrpSpPr/>
+        <p:nvPr/>
+      </p:nvGrpSpPr>
+      <p:grpSpPr/>
+      <p:sp>
+        <p:nvSpPr>
+          <p:cNvPr id="2" name="Rectangle 1"/>
+          <p:cNvSpPr/>
+          <p:nvPr/>
+        </p:nvSpPr>
+        <p:spPr>
+          <a:xfrm>
+            <a:off x="0" y="0"/>
+            <a:ext cx="12191695" cy="6858000"/>
+          </a:xfrm>
+          <a:prstGeom prst="rect">
+            <a:avLst/>
+          </a:prstGeom>
+          <a:solidFill>
+            <a:srgbClr val="FDFBF8"/>
+          </a:solidFill>
+          <a:ln>
+            <a:noFill/>
+          </a:ln>
+          <a:effectLst/>
+        </p:spPr>
+        <p:style>
+          <a:lnRef idx="1">
+            <a:schemeClr val="accent1"/>
+          </a:lnRef>
+          <a:fillRef idx="3">
+            <a:schemeClr val="accent1"/>
+          </a:fillRef>
+          <a:effectRef idx="2">
+            <a:schemeClr val="accent1"/>
+          </a:effectRef>
+          <a:fontRef idx="minor">
+            <a:schemeClr val="lt1"/>
+          </a:fontRef>
+        </p:style>
+        <p:txBody>
+          <a:bodyPr rtlCol="0" anchor="ctr"/>
+          <a:lstStyle/>
+          <a:p>
+            <a:pPr algn="ctr"/>
+          </a:p>
+        </p:txBody>
+      </p:sp>
+      <p:sp>
+        <p:nvSpPr>
+          <p:cNvPr id="3" name="TextBox 2"/>
+          <p:cNvSpPr txBox="1"/>
+          <p:nvPr/>
+        </p:nvSpPr>
+        <p:spPr>
+          <a:xfrm>
+            <a:off x="502920" y="292608"/>
+            <a:ext cx="11155680" cy="292608"/>
+          </a:xfrm>
+          <a:prstGeom prst="rect">
+            <a:avLst/>
+          </a:prstGeom>
+          <a:noFill/>
+        </p:spPr>
+        <p:txBody>
+          <a:bodyPr wrap="none">
+            <a:spAutoFit/>
+          </a:bodyPr>
+          <a:lstStyle/>
+          <a:p>
+            <a:r>
+              <a:rPr sz="1100" b="1">
+                <a:solidFill>
+                  <a:srgbClr val="DC756A"/>
+                </a:solidFill>
+                <a:latin typeface="Calibri"/>
+              </a:rPr>
+              <a:t>CON SỐ PHẢI NHỚ</a:t>
+            </a:r>
+          </a:p>
+        </p:txBody>
+      </p:sp>
+      <p:sp>
+        <p:nvSpPr>
+          <p:cNvPr id="4" name="TextBox 3"/>
+          <p:cNvSpPr txBox="1"/>
+          <p:nvPr/>
+        </p:nvSpPr>
+        <p:spPr>
+          <a:xfrm>
+            <a:off x="502920" y="603504"/>
+            <a:ext cx="11155680" cy="731520"/>
+          </a:xfrm>
+          <a:prstGeom prst="rect">
+            <a:avLst/>
+          </a:prstGeom>
+          <a:noFill/>
+        </p:spPr>
+        <p:txBody>
+          <a:bodyPr wrap="square">
+            <a:spAutoFit/>
+          </a:bodyPr>
+          <a:lstStyle/>
+          <a:p>
+            <a:r>
+              <a:rPr sz="2700" b="1">
+                <a:solidFill>
+                  <a:srgbClr val="3A2B28"/>
+                </a:solidFill>
+                <a:latin typeface="Cambria"/>
+              </a:rPr>
+              <a:t>Thông điệp cảm xúc được truyền đi thế nào?</a:t>
+            </a:r>
+          </a:p>
+        </p:txBody>
+      </p:sp>
+      <p:sp>
+        <p:nvSpPr>
+          <p:cNvPr id="5" name="Rounded Rectangle 4"/>
+          <p:cNvSpPr/>
+          <p:nvPr/>
+        </p:nvSpPr>
+        <p:spPr>
+          <a:xfrm>
+            <a:off x="502920" y="1783080"/>
+            <a:ext cx="3575304" cy="3429000"/>
+          </a:xfrm>
+          <a:prstGeom prst="roundRect">
+            <a:avLst>
+              <a:gd name="adj" fmla="val 7000"/>
+            </a:avLst>
+          </a:prstGeom>
+          <a:solidFill>
+            <a:srgbClr val="FFFFFF"/>
+          </a:solidFill>
+          <a:ln w="15875">
+            <a:solidFill>
+              <a:srgbClr val="FBCEC9"/>
+            </a:solidFill>
+          </a:ln>
+          <a:effectLst/>
+        </p:spPr>
+        <p:style>
+          <a:lnRef idx="1">
+            <a:schemeClr val="accent1"/>
+          </a:lnRef>
+          <a:fillRef idx="3">
+            <a:schemeClr val="accent1"/>
+          </a:fillRef>
+          <a:effectRef idx="2">
+            <a:schemeClr val="accent1"/>
+          </a:effectRef>
+          <a:fontRef idx="minor">
+            <a:schemeClr val="lt1"/>
+          </a:fontRef>
+        </p:style>
+        <p:txBody>
+          <a:bodyPr rtlCol="0" anchor="ctr" wrap="square" lIns="182880" rIns="182880" tIns="274320" bIns="182880"/>
+          <a:lstStyle/>
+          <a:p>
+            <a:pPr algn="ctr"/>
+            <a:r>
+              <a:rPr sz="5800" b="1">
+                <a:solidFill>
+                  <a:srgbClr val="DC756A"/>
+                </a:solidFill>
+                <a:latin typeface="Cambria"/>
+              </a:rPr>
+              <a:t>7%</a:t>
+            </a:r>
+          </a:p>
+          <a:p>
+            <a:pPr algn="ctr"/>
+            <a:r>
+              <a:rPr sz="1400" b="1">
+                <a:solidFill>
+                  <a:srgbClr val="AC4D33"/>
+                </a:solidFill>
+                <a:latin typeface="Calibri"/>
+              </a:rPr>
+              <a:t>TỪ NGỮ</a:t>
+            </a:r>
+          </a:p>
+          <a:p>
+            <a:pPr algn="ctr">
+              <a:spcBef>
+                <a:spcPts val="1200"/>
+              </a:spcBef>
+            </a:pPr>
+            <a:r>
+              <a:rPr sz="1250">
+                <a:solidFill>
+                  <a:srgbClr val="3A2B28"/>
+                </a:solidFill>
+                <a:latin typeface="Calibri"/>
+              </a:rPr>
+              <a:t>Nội dung lời nói — phần nhỏ nhất, dù ta thường đầu tư nhiều nhất vào đây</a:t>
+            </a:r>
+          </a:p>
+        </p:txBody>
+      </p:sp>
+      <p:sp>
+        <p:nvSpPr>
+          <p:cNvPr id="6" name="Rounded Rectangle 5"/>
+          <p:cNvSpPr/>
+          <p:nvPr/>
+        </p:nvSpPr>
+        <p:spPr>
+          <a:xfrm>
+            <a:off x="4315968" y="1783080"/>
+            <a:ext cx="3575304" cy="3429000"/>
+          </a:xfrm>
+          <a:prstGeom prst="roundRect">
+            <a:avLst>
+              <a:gd name="adj" fmla="val 7000"/>
+            </a:avLst>
+          </a:prstGeom>
+          <a:solidFill>
+            <a:srgbClr val="FFFFFF"/>
+          </a:solidFill>
+          <a:ln w="15875">
+            <a:solidFill>
+              <a:srgbClr val="FBCEC9"/>
+            </a:solidFill>
+          </a:ln>
+          <a:effectLst/>
+        </p:spPr>
+        <p:style>
+          <a:lnRef idx="1">
+            <a:schemeClr val="accent1"/>
+          </a:lnRef>
+          <a:fillRef idx="3">
+            <a:schemeClr val="accent1"/>
+          </a:fillRef>
+          <a:effectRef idx="2">
+            <a:schemeClr val="accent1"/>
+          </a:effectRef>
+          <a:fontRef idx="minor">
+            <a:schemeClr val="lt1"/>
+          </a:fontRef>
+        </p:style>
+        <p:txBody>
+          <a:bodyPr rtlCol="0" anchor="ctr" wrap="square" lIns="182880" rIns="182880" tIns="274320" bIns="182880"/>
+          <a:lstStyle/>
+          <a:p>
+            <a:pPr algn="ctr"/>
+            <a:r>
+              <a:rPr sz="5800" b="1">
+                <a:solidFill>
+                  <a:srgbClr val="DC756A"/>
+                </a:solidFill>
+                <a:latin typeface="Cambria"/>
+              </a:rPr>
+              <a:t>38%</a:t>
+            </a:r>
+          </a:p>
+          <a:p>
+            <a:pPr algn="ctr"/>
+            <a:r>
+              <a:rPr sz="1400" b="1">
+                <a:solidFill>
+                  <a:srgbClr val="AC4D33"/>
+                </a:solidFill>
+                <a:latin typeface="Calibri"/>
+              </a:rPr>
+              <a:t>GIỌNG NÓI</a:t>
+            </a:r>
+          </a:p>
+          <a:p>
+            <a:pPr algn="ctr">
+              <a:spcBef>
+                <a:spcPts val="1200"/>
+              </a:spcBef>
+            </a:pPr>
+            <a:r>
+              <a:rPr sz="1250">
+                <a:solidFill>
+                  <a:srgbClr val="3A2B28"/>
+                </a:solidFill>
+                <a:latin typeface="Calibri"/>
+              </a:rPr>
+              <a:t>Âm lượng, tốc độ, ngữ điệu, khoảng dừng</a:t>
+            </a:r>
+          </a:p>
+        </p:txBody>
+      </p:sp>
+      <p:sp>
+        <p:nvSpPr>
+          <p:cNvPr id="7" name="Rounded Rectangle 6"/>
+          <p:cNvSpPr/>
+          <p:nvPr/>
+        </p:nvSpPr>
+        <p:spPr>
+          <a:xfrm>
+            <a:off x="8129016" y="1783080"/>
+            <a:ext cx="3575304" cy="3429000"/>
+          </a:xfrm>
+          <a:prstGeom prst="roundRect">
+            <a:avLst>
+              <a:gd name="adj" fmla="val 7000"/>
+            </a:avLst>
+          </a:prstGeom>
+          <a:solidFill>
+            <a:srgbClr val="FFFFFF"/>
+          </a:solidFill>
+          <a:ln w="15875">
+            <a:solidFill>
+              <a:srgbClr val="FBCEC9"/>
+            </a:solidFill>
+          </a:ln>
+          <a:effectLst/>
+        </p:spPr>
+        <p:style>
+          <a:lnRef idx="1">
+            <a:schemeClr val="accent1"/>
+          </a:lnRef>
+          <a:fillRef idx="3">
+            <a:schemeClr val="accent1"/>
+          </a:fillRef>
+          <a:effectRef idx="2">
+            <a:schemeClr val="accent1"/>
+          </a:effectRef>
+          <a:fontRef idx="minor">
+            <a:schemeClr val="lt1"/>
+          </a:fontRef>
+        </p:style>
+        <p:txBody>
+          <a:bodyPr rtlCol="0" anchor="ctr" wrap="square" lIns="182880" rIns="182880" tIns="274320" bIns="182880"/>
+          <a:lstStyle/>
+          <a:p>
+            <a:pPr algn="ctr"/>
+            <a:r>
+              <a:rPr sz="5800" b="1">
+                <a:solidFill>
+                  <a:srgbClr val="DC756A"/>
+                </a:solidFill>
+                <a:latin typeface="Cambria"/>
+              </a:rPr>
+              <a:t>55%</a:t>
+            </a:r>
+          </a:p>
+          <a:p>
+            <a:pPr algn="ctr"/>
+            <a:r>
+              <a:rPr sz="1400" b="1">
+                <a:solidFill>
+                  <a:srgbClr val="AC4D33"/>
+                </a:solidFill>
+                <a:latin typeface="Calibri"/>
+              </a:rPr>
+              <a:t>NGÔN NGỮ CƠ THỂ</a:t>
+            </a:r>
+          </a:p>
+          <a:p>
+            <a:pPr algn="ctr">
+              <a:spcBef>
+                <a:spcPts val="1200"/>
+              </a:spcBef>
+            </a:pPr>
+            <a:r>
+              <a:rPr sz="1250">
+                <a:solidFill>
+                  <a:srgbClr val="3A2B28"/>
+                </a:solidFill>
+                <a:latin typeface="Calibri"/>
+              </a:rPr>
+              <a:t>Ánh mắt, nét mặt, cử chỉ, tư thế, khoảng cách</a:t>
+            </a:r>
+          </a:p>
+        </p:txBody>
+      </p:sp>
+      <p:sp>
+        <p:nvSpPr>
+          <p:cNvPr id="8" name="Rounded Rectangle 7"/>
+          <p:cNvSpPr/>
+          <p:nvPr/>
+        </p:nvSpPr>
+        <p:spPr>
+          <a:xfrm>
+            <a:off x="502920" y="5440680"/>
+            <a:ext cx="11201400" cy="685800"/>
+          </a:xfrm>
+          <a:prstGeom prst="roundRect">
+            <a:avLst>
+              <a:gd name="adj" fmla="val 12000"/>
+            </a:avLst>
+          </a:prstGeom>
+          <a:solidFill>
+            <a:srgbClr val="FDF1EF"/>
+          </a:solidFill>
+          <a:ln w="12700">
+            <a:solidFill>
+              <a:srgbClr val="FBCEC9"/>
+            </a:solidFill>
+          </a:ln>
+          <a:effectLst/>
+        </p:spPr>
+        <p:style>
+          <a:lnRef idx="1">
+            <a:schemeClr val="accent1"/>
+          </a:lnRef>
+          <a:fillRef idx="3">
+            <a:schemeClr val="accent1"/>
+          </a:fillRef>
+          <a:effectRef idx="2">
+            <a:schemeClr val="accent1"/>
+          </a:effectRef>
+          <a:fontRef idx="minor">
+            <a:schemeClr val="lt1"/>
+          </a:fontRef>
+        </p:style>
+        <p:txBody>
+          <a:bodyPr rtlCol="0" anchor="ctr" wrap="square" lIns="201168" rIns="201168"/>
+          <a:lstStyle/>
+          <a:p>
+            <a:pPr algn="ctr"/>
+            <a:r>
+              <a:rPr sz="1300">
+                <a:solidFill>
+                  <a:srgbClr val="3A2B28"/>
+                </a:solidFill>
+                <a:latin typeface="Calibri"/>
+              </a:rPr>
+              <a:t>Nghiên cứu của Albert Mehrabian — chỉ áp dụng cho thông điệp mang tính CẢM XÚC, không phải mọi tình huống giao tiếp.</a:t>
+            </a:r>
+          </a:p>
+        </p:txBody>
+      </p:sp>
+      <p:sp>
+        <p:nvSpPr>
+          <p:cNvPr id="9" name="TextBox 8"/>
+          <p:cNvSpPr txBox="1"/>
+          <p:nvPr/>
+        </p:nvSpPr>
+        <p:spPr>
+          <a:xfrm>
+            <a:off x="502920" y="6419088"/>
+            <a:ext cx="7772400" cy="292608"/>
+          </a:xfrm>
+          <a:prstGeom prst="rect">
+            <a:avLst/>
+          </a:prstGeom>
+          <a:noFill/>
+        </p:spPr>
+        <p:txBody>
+          <a:bodyPr wrap="none">
+            <a:spAutoFit/>
+          </a:bodyPr>
+          <a:lstStyle/>
+          <a:p>
+            <a:r>
+              <a:rPr sz="900">
+                <a:solidFill>
+                  <a:srgbClr val="8A7A76"/>
+                </a:solidFill>
+                <a:latin typeface="Calibri"/>
+              </a:rPr>
+              <a:t>Je m'appelle Huong  •  GV. Đỗ Thùy Hương  •  EC1103</a:t>
+            </a:r>
+          </a:p>
+        </p:txBody>
+      </p:sp>
+      <p:sp>
+        <p:nvSpPr>
+          <p:cNvPr id="10" name="TextBox 9"/>
+          <p:cNvSpPr txBox="1"/>
+          <p:nvPr/>
+        </p:nvSpPr>
+        <p:spPr>
+          <a:xfrm>
+            <a:off x="9326880" y="6419088"/>
+            <a:ext cx="1920240" cy="292608"/>
+          </a:xfrm>
+          <a:prstGeom prst="rect">
+            <a:avLst/>
+          </a:prstGeom>
+          <a:noFill/>
+        </p:spPr>
+        <p:txBody>
+          <a:bodyPr wrap="none">
+            <a:spAutoFit/>
+          </a:bodyPr>
+          <a:lstStyle/>
+          <a:p>
+            <a:pPr algn="r"/>
+            <a:r>
+              <a:rPr sz="900">
+                <a:solidFill>
+                  <a:srgbClr val="8A7A76"/>
+                </a:solidFill>
+                <a:latin typeface="Calibri"/>
+              </a:rPr>
+              <a:t>Chương 1</a:t>
+            </a:r>
+          </a:p>
+        </p:txBody>
+      </p:sp>
+    </p:spTree>
+  </p:cSld>
+  <p:clrMapOvr>
+    <a:masterClrMapping/>
+  </p:clrMapOvr>
+</p:sld>
+</file>
+
+<file path=ppt/slides/slide12.xml><?xml version="1.0" encoding="utf-8"?>
 <p:sld xmlns:a="http://schemas.openxmlformats.org/drawingml/2006/main" xmlns:r="http://schemas.openxmlformats.org/officeDocument/2006/relationships" xmlns:p="http://schemas.openxmlformats.org/presentationml/2006/main">
   <p:cSld name="Slide 10">
     <p:bg>
@@ -3651,7 +5058,328 @@
 </p:sld>
 </file>
 
-<file path=ppt/slides/slide11.xml><?xml version="1.0" encoding="utf-8"?>
+<file path=ppt/slides/slide13.xml><?xml version="1.0" encoding="utf-8"?>
+<p:sld xmlns:a="http://schemas.openxmlformats.org/drawingml/2006/main" xmlns:p="http://schemas.openxmlformats.org/presentationml/2006/main" xmlns:r="http://schemas.openxmlformats.org/officeDocument/2006/relationships">
+  <p:cSld>
+    <p:spTree>
+      <p:nvGrpSpPr>
+        <p:cNvPr id="1" name=""/>
+        <p:cNvGrpSpPr/>
+        <p:nvPr/>
+      </p:nvGrpSpPr>
+      <p:grpSpPr/>
+      <p:sp>
+        <p:nvSpPr>
+          <p:cNvPr id="2" name="Rectangle 1"/>
+          <p:cNvSpPr/>
+          <p:nvPr/>
+        </p:nvSpPr>
+        <p:spPr>
+          <a:xfrm>
+            <a:off x="0" y="0"/>
+            <a:ext cx="12191695" cy="6858000"/>
+          </a:xfrm>
+          <a:prstGeom prst="rect">
+            <a:avLst/>
+          </a:prstGeom>
+          <a:solidFill>
+            <a:srgbClr val="FDFBF8"/>
+          </a:solidFill>
+          <a:ln>
+            <a:noFill/>
+          </a:ln>
+          <a:effectLst/>
+        </p:spPr>
+        <p:style>
+          <a:lnRef idx="1">
+            <a:schemeClr val="accent1"/>
+          </a:lnRef>
+          <a:fillRef idx="3">
+            <a:schemeClr val="accent1"/>
+          </a:fillRef>
+          <a:effectRef idx="2">
+            <a:schemeClr val="accent1"/>
+          </a:effectRef>
+          <a:fontRef idx="minor">
+            <a:schemeClr val="lt1"/>
+          </a:fontRef>
+        </p:style>
+        <p:txBody>
+          <a:bodyPr rtlCol="0" anchor="ctr"/>
+          <a:lstStyle/>
+          <a:p>
+            <a:pPr algn="ctr"/>
+          </a:p>
+        </p:txBody>
+      </p:sp>
+      <p:sp>
+        <p:nvSpPr>
+          <p:cNvPr id="3" name="Rectangle 2"/>
+          <p:cNvSpPr/>
+          <p:nvPr/>
+        </p:nvSpPr>
+        <p:spPr>
+          <a:xfrm>
+            <a:off x="0" y="2103120"/>
+            <a:ext cx="12191695" cy="2743200"/>
+          </a:xfrm>
+          <a:prstGeom prst="rect">
+            <a:avLst/>
+          </a:prstGeom>
+          <a:solidFill>
+            <a:srgbClr val="FDF1EF"/>
+          </a:solidFill>
+          <a:ln>
+            <a:noFill/>
+          </a:ln>
+          <a:effectLst/>
+        </p:spPr>
+        <p:style>
+          <a:lnRef idx="1">
+            <a:schemeClr val="accent1"/>
+          </a:lnRef>
+          <a:fillRef idx="3">
+            <a:schemeClr val="accent1"/>
+          </a:fillRef>
+          <a:effectRef idx="2">
+            <a:schemeClr val="accent1"/>
+          </a:effectRef>
+          <a:fontRef idx="minor">
+            <a:schemeClr val="lt1"/>
+          </a:fontRef>
+        </p:style>
+        <p:txBody>
+          <a:bodyPr rtlCol="0" anchor="ctr"/>
+          <a:lstStyle/>
+          <a:p>
+            <a:pPr algn="ctr"/>
+          </a:p>
+        </p:txBody>
+      </p:sp>
+      <p:sp>
+        <p:nvSpPr>
+          <p:cNvPr id="4" name="Rectangle 3"/>
+          <p:cNvSpPr/>
+          <p:nvPr/>
+        </p:nvSpPr>
+        <p:spPr>
+          <a:xfrm>
+            <a:off x="0" y="0"/>
+            <a:ext cx="274320" cy="6858000"/>
+          </a:xfrm>
+          <a:prstGeom prst="rect">
+            <a:avLst/>
+          </a:prstGeom>
+          <a:solidFill>
+            <a:srgbClr val="DC756A"/>
+          </a:solidFill>
+          <a:ln>
+            <a:noFill/>
+          </a:ln>
+          <a:effectLst/>
+        </p:spPr>
+        <p:style>
+          <a:lnRef idx="1">
+            <a:schemeClr val="accent1"/>
+          </a:lnRef>
+          <a:fillRef idx="3">
+            <a:schemeClr val="accent1"/>
+          </a:fillRef>
+          <a:effectRef idx="2">
+            <a:schemeClr val="accent1"/>
+          </a:effectRef>
+          <a:fontRef idx="minor">
+            <a:schemeClr val="lt1"/>
+          </a:fontRef>
+        </p:style>
+        <p:txBody>
+          <a:bodyPr rtlCol="0" anchor="ctr"/>
+          <a:lstStyle/>
+          <a:p>
+            <a:pPr algn="ctr"/>
+          </a:p>
+        </p:txBody>
+      </p:sp>
+      <p:sp>
+        <p:nvSpPr>
+          <p:cNvPr id="5" name="TextBox 4"/>
+          <p:cNvSpPr txBox="1"/>
+          <p:nvPr/>
+        </p:nvSpPr>
+        <p:spPr>
+          <a:xfrm>
+            <a:off x="1280160" y="2377440"/>
+            <a:ext cx="9692640" cy="411480"/>
+          </a:xfrm>
+          <a:prstGeom prst="rect">
+            <a:avLst/>
+          </a:prstGeom>
+          <a:noFill/>
+        </p:spPr>
+        <p:txBody>
+          <a:bodyPr wrap="none">
+            <a:spAutoFit/>
+          </a:bodyPr>
+          <a:lstStyle/>
+          <a:p>
+            <a:r>
+              <a:rPr sz="1500" b="1">
+                <a:solidFill>
+                  <a:srgbClr val="DC756A"/>
+                </a:solidFill>
+                <a:latin typeface="Calibri"/>
+              </a:rPr>
+              <a:t>MỤC 1.4 – 1.5</a:t>
+            </a:r>
+          </a:p>
+        </p:txBody>
+      </p:sp>
+      <p:sp>
+        <p:nvSpPr>
+          <p:cNvPr id="6" name="TextBox 5"/>
+          <p:cNvSpPr txBox="1"/>
+          <p:nvPr/>
+        </p:nvSpPr>
+        <p:spPr>
+          <a:xfrm>
+            <a:off x="1280160" y="2788920"/>
+            <a:ext cx="9601200" cy="1371600"/>
+          </a:xfrm>
+          <a:prstGeom prst="rect">
+            <a:avLst/>
+          </a:prstGeom>
+          <a:noFill/>
+        </p:spPr>
+        <p:txBody>
+          <a:bodyPr wrap="square">
+            <a:spAutoFit/>
+          </a:bodyPr>
+          <a:lstStyle/>
+          <a:p>
+            <a:r>
+              <a:rPr sz="3800" b="1">
+                <a:solidFill>
+                  <a:srgbClr val="AC4D33"/>
+                </a:solidFill>
+                <a:latin typeface="Cambria"/>
+              </a:rPr>
+              <a:t>Yếu tố ảnh hưởng và nguyên tắc</a:t>
+            </a:r>
+          </a:p>
+        </p:txBody>
+      </p:sp>
+      <p:sp>
+        <p:nvSpPr>
+          <p:cNvPr id="7" name="TextBox 6"/>
+          <p:cNvSpPr txBox="1"/>
+          <p:nvPr/>
+        </p:nvSpPr>
+        <p:spPr>
+          <a:xfrm>
+            <a:off x="1280160" y="4224528"/>
+            <a:ext cx="9418320" cy="640080"/>
+          </a:xfrm>
+          <a:prstGeom prst="rect">
+            <a:avLst/>
+          </a:prstGeom>
+          <a:noFill/>
+        </p:spPr>
+        <p:txBody>
+          <a:bodyPr wrap="square">
+            <a:spAutoFit/>
+          </a:bodyPr>
+          <a:lstStyle/>
+          <a:p>
+            <a:r>
+              <a:rPr sz="1450" i="1">
+                <a:solidFill>
+                  <a:srgbClr val="8A7A76"/>
+                </a:solidFill>
+                <a:latin typeface="Calibri"/>
+              </a:rPr>
+              <a:t>Điều gì làm hỏng một cuộc giao tiếp, và năm nguyên tắc giúp ta tránh được điều đó.</a:t>
+            </a:r>
+          </a:p>
+        </p:txBody>
+      </p:sp>
+      <p:sp>
+        <p:nvSpPr>
+          <p:cNvPr id="8" name="TextBox 7"/>
+          <p:cNvSpPr txBox="1"/>
+          <p:nvPr/>
+        </p:nvSpPr>
+        <p:spPr>
+          <a:xfrm>
+            <a:off x="502920" y="6419088"/>
+            <a:ext cx="7772400" cy="292608"/>
+          </a:xfrm>
+          <a:prstGeom prst="rect">
+            <a:avLst/>
+          </a:prstGeom>
+          <a:noFill/>
+        </p:spPr>
+        <p:txBody>
+          <a:bodyPr wrap="none">
+            <a:spAutoFit/>
+          </a:bodyPr>
+          <a:lstStyle/>
+          <a:p>
+            <a:r>
+              <a:rPr sz="900">
+                <a:solidFill>
+                  <a:srgbClr val="8A7A76"/>
+                </a:solidFill>
+                <a:latin typeface="Calibri"/>
+              </a:rPr>
+              <a:t>Je m'appelle Huong  •  GV. Đỗ Thùy Hương  •  EC1103</a:t>
+            </a:r>
+          </a:p>
+        </p:txBody>
+      </p:sp>
+      <p:sp>
+        <p:nvSpPr>
+          <p:cNvPr id="9" name="TextBox 8"/>
+          <p:cNvSpPr txBox="1"/>
+          <p:nvPr/>
+        </p:nvSpPr>
+        <p:spPr>
+          <a:xfrm>
+            <a:off x="9326880" y="6419088"/>
+            <a:ext cx="1920240" cy="292608"/>
+          </a:xfrm>
+          <a:prstGeom prst="rect">
+            <a:avLst/>
+          </a:prstGeom>
+          <a:noFill/>
+        </p:spPr>
+        <p:txBody>
+          <a:bodyPr wrap="none">
+            <a:spAutoFit/>
+          </a:bodyPr>
+          <a:lstStyle/>
+          <a:p>
+            <a:pPr algn="r"/>
+            <a:r>
+              <a:rPr sz="900">
+                <a:solidFill>
+                  <a:srgbClr val="8A7A76"/>
+                </a:solidFill>
+                <a:latin typeface="Calibri"/>
+              </a:rPr>
+              <a:t>Chương 1</a:t>
+            </a:r>
+          </a:p>
+        </p:txBody>
+      </p:sp>
+    </p:spTree>
+  </p:cSld>
+  <p:clrMapOvr>
+    <a:masterClrMapping/>
+  </p:clrMapOvr>
+</p:sld>
+</file>
+
+<file path=ppt/slides/slide14.xml><?xml version="1.0" encoding="utf-8"?>
 <p:sld xmlns:a="http://schemas.openxmlformats.org/drawingml/2006/main" xmlns:r="http://schemas.openxmlformats.org/officeDocument/2006/relationships" xmlns:p="http://schemas.openxmlformats.org/presentationml/2006/main">
   <p:cSld name="Slide 11">
     <p:bg>
@@ -3985,7 +5713,7 @@
 </p:sld>
 </file>
 
-<file path=ppt/slides/slide12.xml><?xml version="1.0" encoding="utf-8"?>
+<file path=ppt/slides/slide15.xml><?xml version="1.0" encoding="utf-8"?>
 <p:sld xmlns:a="http://schemas.openxmlformats.org/drawingml/2006/main" xmlns:r="http://schemas.openxmlformats.org/officeDocument/2006/relationships" xmlns:p="http://schemas.openxmlformats.org/presentationml/2006/main">
   <p:cSld name="Slide 12">
     <p:bg>
@@ -4840,7 +6568,7 @@
 </p:sld>
 </file>
 
-<file path=ppt/slides/slide13.xml><?xml version="1.0" encoding="utf-8"?>
+<file path=ppt/slides/slide16.xml><?xml version="1.0" encoding="utf-8"?>
 <p:sld xmlns:a="http://schemas.openxmlformats.org/drawingml/2006/main" xmlns:r="http://schemas.openxmlformats.org/officeDocument/2006/relationships" xmlns:p="http://schemas.openxmlformats.org/presentationml/2006/main">
   <p:cSld name="Slide 13">
     <p:bg>
@@ -5571,7 +7299,7 @@
 </p:sld>
 </file>
 
-<file path=ppt/slides/slide14.xml><?xml version="1.0" encoding="utf-8"?>
+<file path=ppt/slides/slide17.xml><?xml version="1.0" encoding="utf-8"?>
 <p:sld xmlns:a="http://schemas.openxmlformats.org/drawingml/2006/main" xmlns:r="http://schemas.openxmlformats.org/officeDocument/2006/relationships" xmlns:p="http://schemas.openxmlformats.org/presentationml/2006/main">
   <p:cSld name="Slide 14">
     <p:bg>
@@ -6107,7 +7835,7 @@
 </p:sld>
 </file>
 
-<file path=ppt/slides/slide15.xml><?xml version="1.0" encoding="utf-8"?>
+<file path=ppt/slides/slide18.xml><?xml version="1.0" encoding="utf-8"?>
 <p:sld xmlns:a="http://schemas.openxmlformats.org/drawingml/2006/main" xmlns:r="http://schemas.openxmlformats.org/officeDocument/2006/relationships" xmlns:p="http://schemas.openxmlformats.org/presentationml/2006/main">
   <p:cSld name="Slide 15">
     <p:bg>
@@ -6874,7 +8602,7 @@
 </p:sld>
 </file>
 
-<file path=ppt/slides/slide16.xml><?xml version="1.0" encoding="utf-8"?>
+<file path=ppt/slides/slide19.xml><?xml version="1.0" encoding="utf-8"?>
 <p:sld xmlns:a="http://schemas.openxmlformats.org/drawingml/2006/main" xmlns:r="http://schemas.openxmlformats.org/officeDocument/2006/relationships" xmlns:p="http://schemas.openxmlformats.org/presentationml/2006/main">
   <p:cSld name="Slide 16">
     <p:bg>
@@ -7399,1159 +9127,6 @@
               <a:t>Slide bài giảng, tình huống và bài tập do GV. Đỗ Thùy Hương biên soạn; cung cấp sau mỗi buổi học trên nhóm lớp.</a:t>
             </a:r>
             <a:endParaRPr lang="en-US" sz="1500" dirty="0"/>
-          </a:p>
-        </p:txBody>
-      </p:sp>
-    </p:spTree>
-  </p:cSld>
-  <p:clrMapOvr>
-    <a:masterClrMapping/>
-  </p:clrMapOvr>
-</p:sld>
-</file>
-
-<file path=ppt/slides/slide17.xml><?xml version="1.0" encoding="utf-8"?>
-<p:sld xmlns:a="http://schemas.openxmlformats.org/drawingml/2006/main" xmlns:p="http://schemas.openxmlformats.org/presentationml/2006/main" xmlns:r="http://schemas.openxmlformats.org/officeDocument/2006/relationships">
-  <p:cSld>
-    <p:spTree>
-      <p:nvGrpSpPr>
-        <p:cNvPr id="1" name=""/>
-        <p:cNvGrpSpPr/>
-        <p:nvPr/>
-      </p:nvGrpSpPr>
-      <p:grpSpPr/>
-      <p:sp>
-        <p:nvSpPr>
-          <p:cNvPr id="2" name="Rectangle 1"/>
-          <p:cNvSpPr/>
-          <p:nvPr/>
-        </p:nvSpPr>
-        <p:spPr>
-          <a:xfrm>
-            <a:off x="0" y="0"/>
-            <a:ext cx="12191695" cy="6858000"/>
-          </a:xfrm>
-          <a:prstGeom prst="rect">
-            <a:avLst/>
-          </a:prstGeom>
-          <a:solidFill>
-            <a:srgbClr val="FDFBF8"/>
-          </a:solidFill>
-          <a:ln>
-            <a:noFill/>
-          </a:ln>
-          <a:effectLst/>
-        </p:spPr>
-        <p:style>
-          <a:lnRef idx="1">
-            <a:schemeClr val="accent1"/>
-          </a:lnRef>
-          <a:fillRef idx="3">
-            <a:schemeClr val="accent1"/>
-          </a:fillRef>
-          <a:effectRef idx="2">
-            <a:schemeClr val="accent1"/>
-          </a:effectRef>
-          <a:fontRef idx="minor">
-            <a:schemeClr val="lt1"/>
-          </a:fontRef>
-        </p:style>
-        <p:txBody>
-          <a:bodyPr rtlCol="0" anchor="ctr"/>
-          <a:lstStyle/>
-          <a:p>
-            <a:pPr algn="ctr"/>
-          </a:p>
-        </p:txBody>
-      </p:sp>
-      <p:sp>
-        <p:nvSpPr>
-          <p:cNvPr id="3" name="TextBox 2"/>
-          <p:cNvSpPr txBox="1"/>
-          <p:nvPr/>
-        </p:nvSpPr>
-        <p:spPr>
-          <a:xfrm>
-            <a:off x="502920" y="292608"/>
-            <a:ext cx="11155680" cy="292608"/>
-          </a:xfrm>
-          <a:prstGeom prst="rect">
-            <a:avLst/>
-          </a:prstGeom>
-          <a:noFill/>
-        </p:spPr>
-        <p:txBody>
-          <a:bodyPr wrap="none">
-            <a:spAutoFit/>
-          </a:bodyPr>
-          <a:lstStyle/>
-          <a:p>
-            <a:r>
-              <a:rPr sz="1100" b="1">
-                <a:solidFill>
-                  <a:srgbClr val="DC756A"/>
-                </a:solidFill>
-                <a:latin typeface="Calibri"/>
-              </a:rPr>
-              <a:t>CON SỐ PHẢI NHỚ</a:t>
-            </a:r>
-          </a:p>
-        </p:txBody>
-      </p:sp>
-      <p:sp>
-        <p:nvSpPr>
-          <p:cNvPr id="4" name="TextBox 3"/>
-          <p:cNvSpPr txBox="1"/>
-          <p:nvPr/>
-        </p:nvSpPr>
-        <p:spPr>
-          <a:xfrm>
-            <a:off x="502920" y="603504"/>
-            <a:ext cx="11155680" cy="731520"/>
-          </a:xfrm>
-          <a:prstGeom prst="rect">
-            <a:avLst/>
-          </a:prstGeom>
-          <a:noFill/>
-        </p:spPr>
-        <p:txBody>
-          <a:bodyPr wrap="square">
-            <a:spAutoFit/>
-          </a:bodyPr>
-          <a:lstStyle/>
-          <a:p>
-            <a:r>
-              <a:rPr sz="2700" b="1">
-                <a:solidFill>
-                  <a:srgbClr val="3A2B28"/>
-                </a:solidFill>
-                <a:latin typeface="Cambria"/>
-              </a:rPr>
-              <a:t>Thông điệp cảm xúc được truyền đi thế nào?</a:t>
-            </a:r>
-          </a:p>
-        </p:txBody>
-      </p:sp>
-      <p:sp>
-        <p:nvSpPr>
-          <p:cNvPr id="5" name="Rounded Rectangle 4"/>
-          <p:cNvSpPr/>
-          <p:nvPr/>
-        </p:nvSpPr>
-        <p:spPr>
-          <a:xfrm>
-            <a:off x="502920" y="1783080"/>
-            <a:ext cx="3575304" cy="3429000"/>
-          </a:xfrm>
-          <a:prstGeom prst="roundRect">
-            <a:avLst>
-              <a:gd name="adj" fmla="val 7000"/>
-            </a:avLst>
-          </a:prstGeom>
-          <a:solidFill>
-            <a:srgbClr val="FFFFFF"/>
-          </a:solidFill>
-          <a:ln w="15875">
-            <a:solidFill>
-              <a:srgbClr val="FBCEC9"/>
-            </a:solidFill>
-          </a:ln>
-          <a:effectLst/>
-        </p:spPr>
-        <p:style>
-          <a:lnRef idx="1">
-            <a:schemeClr val="accent1"/>
-          </a:lnRef>
-          <a:fillRef idx="3">
-            <a:schemeClr val="accent1"/>
-          </a:fillRef>
-          <a:effectRef idx="2">
-            <a:schemeClr val="accent1"/>
-          </a:effectRef>
-          <a:fontRef idx="minor">
-            <a:schemeClr val="lt1"/>
-          </a:fontRef>
-        </p:style>
-        <p:txBody>
-          <a:bodyPr rtlCol="0" anchor="ctr" wrap="square" lIns="182880" rIns="182880" tIns="274320" bIns="182880"/>
-          <a:lstStyle/>
-          <a:p>
-            <a:pPr algn="ctr"/>
-            <a:r>
-              <a:rPr sz="5800" b="1">
-                <a:solidFill>
-                  <a:srgbClr val="DC756A"/>
-                </a:solidFill>
-                <a:latin typeface="Cambria"/>
-              </a:rPr>
-              <a:t>7%</a:t>
-            </a:r>
-          </a:p>
-          <a:p>
-            <a:pPr algn="ctr"/>
-            <a:r>
-              <a:rPr sz="1400" b="1">
-                <a:solidFill>
-                  <a:srgbClr val="AC4D33"/>
-                </a:solidFill>
-                <a:latin typeface="Calibri"/>
-              </a:rPr>
-              <a:t>TỪ NGỮ</a:t>
-            </a:r>
-          </a:p>
-          <a:p>
-            <a:pPr algn="ctr">
-              <a:spcBef>
-                <a:spcPts val="1200"/>
-              </a:spcBef>
-            </a:pPr>
-            <a:r>
-              <a:rPr sz="1250">
-                <a:solidFill>
-                  <a:srgbClr val="3A2B28"/>
-                </a:solidFill>
-                <a:latin typeface="Calibri"/>
-              </a:rPr>
-              <a:t>Nội dung lời nói — phần nhỏ nhất, dù ta thường đầu tư nhiều nhất vào đây</a:t>
-            </a:r>
-          </a:p>
-        </p:txBody>
-      </p:sp>
-      <p:sp>
-        <p:nvSpPr>
-          <p:cNvPr id="6" name="Rounded Rectangle 5"/>
-          <p:cNvSpPr/>
-          <p:nvPr/>
-        </p:nvSpPr>
-        <p:spPr>
-          <a:xfrm>
-            <a:off x="4315968" y="1783080"/>
-            <a:ext cx="3575304" cy="3429000"/>
-          </a:xfrm>
-          <a:prstGeom prst="roundRect">
-            <a:avLst>
-              <a:gd name="adj" fmla="val 7000"/>
-            </a:avLst>
-          </a:prstGeom>
-          <a:solidFill>
-            <a:srgbClr val="FFFFFF"/>
-          </a:solidFill>
-          <a:ln w="15875">
-            <a:solidFill>
-              <a:srgbClr val="FBCEC9"/>
-            </a:solidFill>
-          </a:ln>
-          <a:effectLst/>
-        </p:spPr>
-        <p:style>
-          <a:lnRef idx="1">
-            <a:schemeClr val="accent1"/>
-          </a:lnRef>
-          <a:fillRef idx="3">
-            <a:schemeClr val="accent1"/>
-          </a:fillRef>
-          <a:effectRef idx="2">
-            <a:schemeClr val="accent1"/>
-          </a:effectRef>
-          <a:fontRef idx="minor">
-            <a:schemeClr val="lt1"/>
-          </a:fontRef>
-        </p:style>
-        <p:txBody>
-          <a:bodyPr rtlCol="0" anchor="ctr" wrap="square" lIns="182880" rIns="182880" tIns="274320" bIns="182880"/>
-          <a:lstStyle/>
-          <a:p>
-            <a:pPr algn="ctr"/>
-            <a:r>
-              <a:rPr sz="5800" b="1">
-                <a:solidFill>
-                  <a:srgbClr val="DC756A"/>
-                </a:solidFill>
-                <a:latin typeface="Cambria"/>
-              </a:rPr>
-              <a:t>38%</a:t>
-            </a:r>
-          </a:p>
-          <a:p>
-            <a:pPr algn="ctr"/>
-            <a:r>
-              <a:rPr sz="1400" b="1">
-                <a:solidFill>
-                  <a:srgbClr val="AC4D33"/>
-                </a:solidFill>
-                <a:latin typeface="Calibri"/>
-              </a:rPr>
-              <a:t>GIỌNG NÓI</a:t>
-            </a:r>
-          </a:p>
-          <a:p>
-            <a:pPr algn="ctr">
-              <a:spcBef>
-                <a:spcPts val="1200"/>
-              </a:spcBef>
-            </a:pPr>
-            <a:r>
-              <a:rPr sz="1250">
-                <a:solidFill>
-                  <a:srgbClr val="3A2B28"/>
-                </a:solidFill>
-                <a:latin typeface="Calibri"/>
-              </a:rPr>
-              <a:t>Âm lượng, tốc độ, ngữ điệu, khoảng dừng</a:t>
-            </a:r>
-          </a:p>
-        </p:txBody>
-      </p:sp>
-      <p:sp>
-        <p:nvSpPr>
-          <p:cNvPr id="7" name="Rounded Rectangle 6"/>
-          <p:cNvSpPr/>
-          <p:nvPr/>
-        </p:nvSpPr>
-        <p:spPr>
-          <a:xfrm>
-            <a:off x="8129016" y="1783080"/>
-            <a:ext cx="3575304" cy="3429000"/>
-          </a:xfrm>
-          <a:prstGeom prst="roundRect">
-            <a:avLst>
-              <a:gd name="adj" fmla="val 7000"/>
-            </a:avLst>
-          </a:prstGeom>
-          <a:solidFill>
-            <a:srgbClr val="FFFFFF"/>
-          </a:solidFill>
-          <a:ln w="15875">
-            <a:solidFill>
-              <a:srgbClr val="FBCEC9"/>
-            </a:solidFill>
-          </a:ln>
-          <a:effectLst/>
-        </p:spPr>
-        <p:style>
-          <a:lnRef idx="1">
-            <a:schemeClr val="accent1"/>
-          </a:lnRef>
-          <a:fillRef idx="3">
-            <a:schemeClr val="accent1"/>
-          </a:fillRef>
-          <a:effectRef idx="2">
-            <a:schemeClr val="accent1"/>
-          </a:effectRef>
-          <a:fontRef idx="minor">
-            <a:schemeClr val="lt1"/>
-          </a:fontRef>
-        </p:style>
-        <p:txBody>
-          <a:bodyPr rtlCol="0" anchor="ctr" wrap="square" lIns="182880" rIns="182880" tIns="274320" bIns="182880"/>
-          <a:lstStyle/>
-          <a:p>
-            <a:pPr algn="ctr"/>
-            <a:r>
-              <a:rPr sz="5800" b="1">
-                <a:solidFill>
-                  <a:srgbClr val="DC756A"/>
-                </a:solidFill>
-                <a:latin typeface="Cambria"/>
-              </a:rPr>
-              <a:t>55%</a:t>
-            </a:r>
-          </a:p>
-          <a:p>
-            <a:pPr algn="ctr"/>
-            <a:r>
-              <a:rPr sz="1400" b="1">
-                <a:solidFill>
-                  <a:srgbClr val="AC4D33"/>
-                </a:solidFill>
-                <a:latin typeface="Calibri"/>
-              </a:rPr>
-              <a:t>NGÔN NGỮ CƠ THỂ</a:t>
-            </a:r>
-          </a:p>
-          <a:p>
-            <a:pPr algn="ctr">
-              <a:spcBef>
-                <a:spcPts val="1200"/>
-              </a:spcBef>
-            </a:pPr>
-            <a:r>
-              <a:rPr sz="1250">
-                <a:solidFill>
-                  <a:srgbClr val="3A2B28"/>
-                </a:solidFill>
-                <a:latin typeface="Calibri"/>
-              </a:rPr>
-              <a:t>Ánh mắt, nét mặt, cử chỉ, tư thế, khoảng cách</a:t>
-            </a:r>
-          </a:p>
-        </p:txBody>
-      </p:sp>
-      <p:sp>
-        <p:nvSpPr>
-          <p:cNvPr id="8" name="Rounded Rectangle 7"/>
-          <p:cNvSpPr/>
-          <p:nvPr/>
-        </p:nvSpPr>
-        <p:spPr>
-          <a:xfrm>
-            <a:off x="502920" y="5440680"/>
-            <a:ext cx="11201400" cy="685800"/>
-          </a:xfrm>
-          <a:prstGeom prst="roundRect">
-            <a:avLst>
-              <a:gd name="adj" fmla="val 12000"/>
-            </a:avLst>
-          </a:prstGeom>
-          <a:solidFill>
-            <a:srgbClr val="FDF1EF"/>
-          </a:solidFill>
-          <a:ln w="12700">
-            <a:solidFill>
-              <a:srgbClr val="FBCEC9"/>
-            </a:solidFill>
-          </a:ln>
-          <a:effectLst/>
-        </p:spPr>
-        <p:style>
-          <a:lnRef idx="1">
-            <a:schemeClr val="accent1"/>
-          </a:lnRef>
-          <a:fillRef idx="3">
-            <a:schemeClr val="accent1"/>
-          </a:fillRef>
-          <a:effectRef idx="2">
-            <a:schemeClr val="accent1"/>
-          </a:effectRef>
-          <a:fontRef idx="minor">
-            <a:schemeClr val="lt1"/>
-          </a:fontRef>
-        </p:style>
-        <p:txBody>
-          <a:bodyPr rtlCol="0" anchor="ctr" wrap="square" lIns="201168" rIns="201168"/>
-          <a:lstStyle/>
-          <a:p>
-            <a:pPr algn="ctr"/>
-            <a:r>
-              <a:rPr sz="1300">
-                <a:solidFill>
-                  <a:srgbClr val="3A2B28"/>
-                </a:solidFill>
-                <a:latin typeface="Calibri"/>
-              </a:rPr>
-              <a:t>Nghiên cứu của Albert Mehrabian — chỉ áp dụng cho thông điệp mang tính CẢM XÚC, không phải mọi tình huống giao tiếp.</a:t>
-            </a:r>
-          </a:p>
-        </p:txBody>
-      </p:sp>
-      <p:sp>
-        <p:nvSpPr>
-          <p:cNvPr id="9" name="TextBox 8"/>
-          <p:cNvSpPr txBox="1"/>
-          <p:nvPr/>
-        </p:nvSpPr>
-        <p:spPr>
-          <a:xfrm>
-            <a:off x="502920" y="6419088"/>
-            <a:ext cx="7772400" cy="292608"/>
-          </a:xfrm>
-          <a:prstGeom prst="rect">
-            <a:avLst/>
-          </a:prstGeom>
-          <a:noFill/>
-        </p:spPr>
-        <p:txBody>
-          <a:bodyPr wrap="none">
-            <a:spAutoFit/>
-          </a:bodyPr>
-          <a:lstStyle/>
-          <a:p>
-            <a:r>
-              <a:rPr sz="900">
-                <a:solidFill>
-                  <a:srgbClr val="8A7A76"/>
-                </a:solidFill>
-                <a:latin typeface="Calibri"/>
-              </a:rPr>
-              <a:t>Je m'appelle Huong  •  GV. Đỗ Thùy Hương  •  EC1103</a:t>
-            </a:r>
-          </a:p>
-        </p:txBody>
-      </p:sp>
-      <p:sp>
-        <p:nvSpPr>
-          <p:cNvPr id="10" name="TextBox 9"/>
-          <p:cNvSpPr txBox="1"/>
-          <p:nvPr/>
-        </p:nvSpPr>
-        <p:spPr>
-          <a:xfrm>
-            <a:off x="9326880" y="6419088"/>
-            <a:ext cx="1920240" cy="292608"/>
-          </a:xfrm>
-          <a:prstGeom prst="rect">
-            <a:avLst/>
-          </a:prstGeom>
-          <a:noFill/>
-        </p:spPr>
-        <p:txBody>
-          <a:bodyPr wrap="none">
-            <a:spAutoFit/>
-          </a:bodyPr>
-          <a:lstStyle/>
-          <a:p>
-            <a:pPr algn="r"/>
-            <a:r>
-              <a:rPr sz="900">
-                <a:solidFill>
-                  <a:srgbClr val="8A7A76"/>
-                </a:solidFill>
-                <a:latin typeface="Calibri"/>
-              </a:rPr>
-              <a:t>Chương 1</a:t>
-            </a:r>
-          </a:p>
-        </p:txBody>
-      </p:sp>
-    </p:spTree>
-  </p:cSld>
-  <p:clrMapOvr>
-    <a:masterClrMapping/>
-  </p:clrMapOvr>
-</p:sld>
-</file>
-
-<file path=ppt/slides/slide18.xml><?xml version="1.0" encoding="utf-8"?>
-<p:sld xmlns:a="http://schemas.openxmlformats.org/drawingml/2006/main" xmlns:p="http://schemas.openxmlformats.org/presentationml/2006/main" xmlns:r="http://schemas.openxmlformats.org/officeDocument/2006/relationships">
-  <p:cSld>
-    <p:spTree>
-      <p:nvGrpSpPr>
-        <p:cNvPr id="1" name=""/>
-        <p:cNvGrpSpPr/>
-        <p:nvPr/>
-      </p:nvGrpSpPr>
-      <p:grpSpPr/>
-      <p:sp>
-        <p:nvSpPr>
-          <p:cNvPr id="2" name="Rectangle 1"/>
-          <p:cNvSpPr/>
-          <p:nvPr/>
-        </p:nvSpPr>
-        <p:spPr>
-          <a:xfrm>
-            <a:off x="0" y="0"/>
-            <a:ext cx="12191695" cy="6858000"/>
-          </a:xfrm>
-          <a:prstGeom prst="rect">
-            <a:avLst/>
-          </a:prstGeom>
-          <a:solidFill>
-            <a:srgbClr val="FDFBF8"/>
-          </a:solidFill>
-          <a:ln>
-            <a:noFill/>
-          </a:ln>
-          <a:effectLst/>
-        </p:spPr>
-        <p:style>
-          <a:lnRef idx="1">
-            <a:schemeClr val="accent1"/>
-          </a:lnRef>
-          <a:fillRef idx="3">
-            <a:schemeClr val="accent1"/>
-          </a:fillRef>
-          <a:effectRef idx="2">
-            <a:schemeClr val="accent1"/>
-          </a:effectRef>
-          <a:fontRef idx="minor">
-            <a:schemeClr val="lt1"/>
-          </a:fontRef>
-        </p:style>
-        <p:txBody>
-          <a:bodyPr rtlCol="0" anchor="ctr"/>
-          <a:lstStyle/>
-          <a:p>
-            <a:pPr algn="ctr"/>
-          </a:p>
-        </p:txBody>
-      </p:sp>
-      <p:sp>
-        <p:nvSpPr>
-          <p:cNvPr id="3" name="Rectangle 2"/>
-          <p:cNvSpPr/>
-          <p:nvPr/>
-        </p:nvSpPr>
-        <p:spPr>
-          <a:xfrm>
-            <a:off x="0" y="2103120"/>
-            <a:ext cx="12191695" cy="2743200"/>
-          </a:xfrm>
-          <a:prstGeom prst="rect">
-            <a:avLst/>
-          </a:prstGeom>
-          <a:solidFill>
-            <a:srgbClr val="FDF1EF"/>
-          </a:solidFill>
-          <a:ln>
-            <a:noFill/>
-          </a:ln>
-          <a:effectLst/>
-        </p:spPr>
-        <p:style>
-          <a:lnRef idx="1">
-            <a:schemeClr val="accent1"/>
-          </a:lnRef>
-          <a:fillRef idx="3">
-            <a:schemeClr val="accent1"/>
-          </a:fillRef>
-          <a:effectRef idx="2">
-            <a:schemeClr val="accent1"/>
-          </a:effectRef>
-          <a:fontRef idx="minor">
-            <a:schemeClr val="lt1"/>
-          </a:fontRef>
-        </p:style>
-        <p:txBody>
-          <a:bodyPr rtlCol="0" anchor="ctr"/>
-          <a:lstStyle/>
-          <a:p>
-            <a:pPr algn="ctr"/>
-          </a:p>
-        </p:txBody>
-      </p:sp>
-      <p:sp>
-        <p:nvSpPr>
-          <p:cNvPr id="4" name="Rectangle 3"/>
-          <p:cNvSpPr/>
-          <p:nvPr/>
-        </p:nvSpPr>
-        <p:spPr>
-          <a:xfrm>
-            <a:off x="0" y="0"/>
-            <a:ext cx="274320" cy="6858000"/>
-          </a:xfrm>
-          <a:prstGeom prst="rect">
-            <a:avLst/>
-          </a:prstGeom>
-          <a:solidFill>
-            <a:srgbClr val="DC756A"/>
-          </a:solidFill>
-          <a:ln>
-            <a:noFill/>
-          </a:ln>
-          <a:effectLst/>
-        </p:spPr>
-        <p:style>
-          <a:lnRef idx="1">
-            <a:schemeClr val="accent1"/>
-          </a:lnRef>
-          <a:fillRef idx="3">
-            <a:schemeClr val="accent1"/>
-          </a:fillRef>
-          <a:effectRef idx="2">
-            <a:schemeClr val="accent1"/>
-          </a:effectRef>
-          <a:fontRef idx="minor">
-            <a:schemeClr val="lt1"/>
-          </a:fontRef>
-        </p:style>
-        <p:txBody>
-          <a:bodyPr rtlCol="0" anchor="ctr"/>
-          <a:lstStyle/>
-          <a:p>
-            <a:pPr algn="ctr"/>
-          </a:p>
-        </p:txBody>
-      </p:sp>
-      <p:sp>
-        <p:nvSpPr>
-          <p:cNvPr id="5" name="TextBox 4"/>
-          <p:cNvSpPr txBox="1"/>
-          <p:nvPr/>
-        </p:nvSpPr>
-        <p:spPr>
-          <a:xfrm>
-            <a:off x="1280160" y="2377440"/>
-            <a:ext cx="9692640" cy="411480"/>
-          </a:xfrm>
-          <a:prstGeom prst="rect">
-            <a:avLst/>
-          </a:prstGeom>
-          <a:noFill/>
-        </p:spPr>
-        <p:txBody>
-          <a:bodyPr wrap="none">
-            <a:spAutoFit/>
-          </a:bodyPr>
-          <a:lstStyle/>
-          <a:p>
-            <a:r>
-              <a:rPr sz="1500" b="1">
-                <a:solidFill>
-                  <a:srgbClr val="DC756A"/>
-                </a:solidFill>
-                <a:latin typeface="Calibri"/>
-              </a:rPr>
-              <a:t>MỤC 1.1 – 1.2</a:t>
-            </a:r>
-          </a:p>
-        </p:txBody>
-      </p:sp>
-      <p:sp>
-        <p:nvSpPr>
-          <p:cNvPr id="6" name="TextBox 5"/>
-          <p:cNvSpPr txBox="1"/>
-          <p:nvPr/>
-        </p:nvSpPr>
-        <p:spPr>
-          <a:xfrm>
-            <a:off x="1280160" y="2788920"/>
-            <a:ext cx="9601200" cy="1371600"/>
-          </a:xfrm>
-          <a:prstGeom prst="rect">
-            <a:avLst/>
-          </a:prstGeom>
-          <a:noFill/>
-        </p:spPr>
-        <p:txBody>
-          <a:bodyPr wrap="square">
-            <a:spAutoFit/>
-          </a:bodyPr>
-          <a:lstStyle/>
-          <a:p>
-            <a:r>
-              <a:rPr sz="3800" b="1">
-                <a:solidFill>
-                  <a:srgbClr val="AC4D33"/>
-                </a:solidFill>
-                <a:latin typeface="Cambria"/>
-              </a:rPr>
-              <a:t>Bản chất và phương tiện giao tiếp</a:t>
-            </a:r>
-          </a:p>
-        </p:txBody>
-      </p:sp>
-      <p:sp>
-        <p:nvSpPr>
-          <p:cNvPr id="7" name="TextBox 6"/>
-          <p:cNvSpPr txBox="1"/>
-          <p:nvPr/>
-        </p:nvSpPr>
-        <p:spPr>
-          <a:xfrm>
-            <a:off x="1280160" y="4224528"/>
-            <a:ext cx="9418320" cy="640080"/>
-          </a:xfrm>
-          <a:prstGeom prst="rect">
-            <a:avLst/>
-          </a:prstGeom>
-          <a:noFill/>
-        </p:spPr>
-        <p:txBody>
-          <a:bodyPr wrap="square">
-            <a:spAutoFit/>
-          </a:bodyPr>
-          <a:lstStyle/>
-          <a:p>
-            <a:r>
-              <a:rPr sz="1450" i="1">
-                <a:solidFill>
-                  <a:srgbClr val="8A7A76"/>
-                </a:solidFill>
-                <a:latin typeface="Calibri"/>
-              </a:rPr>
-              <a:t>Hiểu đúng bản chất trước khi luyện kỹ năng: giao tiếp là gì, diễn ra qua những khâu nào, bằng phương tiện gì.</a:t>
-            </a:r>
-          </a:p>
-        </p:txBody>
-      </p:sp>
-      <p:sp>
-        <p:nvSpPr>
-          <p:cNvPr id="8" name="TextBox 7"/>
-          <p:cNvSpPr txBox="1"/>
-          <p:nvPr/>
-        </p:nvSpPr>
-        <p:spPr>
-          <a:xfrm>
-            <a:off x="502920" y="6419088"/>
-            <a:ext cx="7772400" cy="292608"/>
-          </a:xfrm>
-          <a:prstGeom prst="rect">
-            <a:avLst/>
-          </a:prstGeom>
-          <a:noFill/>
-        </p:spPr>
-        <p:txBody>
-          <a:bodyPr wrap="none">
-            <a:spAutoFit/>
-          </a:bodyPr>
-          <a:lstStyle/>
-          <a:p>
-            <a:r>
-              <a:rPr sz="900">
-                <a:solidFill>
-                  <a:srgbClr val="8A7A76"/>
-                </a:solidFill>
-                <a:latin typeface="Calibri"/>
-              </a:rPr>
-              <a:t>Je m'appelle Huong  •  GV. Đỗ Thùy Hương  •  EC1103</a:t>
-            </a:r>
-          </a:p>
-        </p:txBody>
-      </p:sp>
-      <p:sp>
-        <p:nvSpPr>
-          <p:cNvPr id="9" name="TextBox 8"/>
-          <p:cNvSpPr txBox="1"/>
-          <p:nvPr/>
-        </p:nvSpPr>
-        <p:spPr>
-          <a:xfrm>
-            <a:off x="9326880" y="6419088"/>
-            <a:ext cx="1920240" cy="292608"/>
-          </a:xfrm>
-          <a:prstGeom prst="rect">
-            <a:avLst/>
-          </a:prstGeom>
-          <a:noFill/>
-        </p:spPr>
-        <p:txBody>
-          <a:bodyPr wrap="none">
-            <a:spAutoFit/>
-          </a:bodyPr>
-          <a:lstStyle/>
-          <a:p>
-            <a:pPr algn="r"/>
-            <a:r>
-              <a:rPr sz="900">
-                <a:solidFill>
-                  <a:srgbClr val="8A7A76"/>
-                </a:solidFill>
-                <a:latin typeface="Calibri"/>
-              </a:rPr>
-              <a:t>Chương 1</a:t>
-            </a:r>
-          </a:p>
-        </p:txBody>
-      </p:sp>
-    </p:spTree>
-  </p:cSld>
-  <p:clrMapOvr>
-    <a:masterClrMapping/>
-  </p:clrMapOvr>
-</p:sld>
-</file>
-
-<file path=ppt/slides/slide19.xml><?xml version="1.0" encoding="utf-8"?>
-<p:sld xmlns:a="http://schemas.openxmlformats.org/drawingml/2006/main" xmlns:p="http://schemas.openxmlformats.org/presentationml/2006/main" xmlns:r="http://schemas.openxmlformats.org/officeDocument/2006/relationships">
-  <p:cSld>
-    <p:spTree>
-      <p:nvGrpSpPr>
-        <p:cNvPr id="1" name=""/>
-        <p:cNvGrpSpPr/>
-        <p:nvPr/>
-      </p:nvGrpSpPr>
-      <p:grpSpPr/>
-      <p:sp>
-        <p:nvSpPr>
-          <p:cNvPr id="2" name="Rectangle 1"/>
-          <p:cNvSpPr/>
-          <p:nvPr/>
-        </p:nvSpPr>
-        <p:spPr>
-          <a:xfrm>
-            <a:off x="0" y="0"/>
-            <a:ext cx="12191695" cy="6858000"/>
-          </a:xfrm>
-          <a:prstGeom prst="rect">
-            <a:avLst/>
-          </a:prstGeom>
-          <a:solidFill>
-            <a:srgbClr val="FDFBF8"/>
-          </a:solidFill>
-          <a:ln>
-            <a:noFill/>
-          </a:ln>
-          <a:effectLst/>
-        </p:spPr>
-        <p:style>
-          <a:lnRef idx="1">
-            <a:schemeClr val="accent1"/>
-          </a:lnRef>
-          <a:fillRef idx="3">
-            <a:schemeClr val="accent1"/>
-          </a:fillRef>
-          <a:effectRef idx="2">
-            <a:schemeClr val="accent1"/>
-          </a:effectRef>
-          <a:fontRef idx="minor">
-            <a:schemeClr val="lt1"/>
-          </a:fontRef>
-        </p:style>
-        <p:txBody>
-          <a:bodyPr rtlCol="0" anchor="ctr"/>
-          <a:lstStyle/>
-          <a:p>
-            <a:pPr algn="ctr"/>
-          </a:p>
-        </p:txBody>
-      </p:sp>
-      <p:sp>
-        <p:nvSpPr>
-          <p:cNvPr id="3" name="Rectangle 2"/>
-          <p:cNvSpPr/>
-          <p:nvPr/>
-        </p:nvSpPr>
-        <p:spPr>
-          <a:xfrm>
-            <a:off x="0" y="2103120"/>
-            <a:ext cx="12191695" cy="2743200"/>
-          </a:xfrm>
-          <a:prstGeom prst="rect">
-            <a:avLst/>
-          </a:prstGeom>
-          <a:solidFill>
-            <a:srgbClr val="FDF1EF"/>
-          </a:solidFill>
-          <a:ln>
-            <a:noFill/>
-          </a:ln>
-          <a:effectLst/>
-        </p:spPr>
-        <p:style>
-          <a:lnRef idx="1">
-            <a:schemeClr val="accent1"/>
-          </a:lnRef>
-          <a:fillRef idx="3">
-            <a:schemeClr val="accent1"/>
-          </a:fillRef>
-          <a:effectRef idx="2">
-            <a:schemeClr val="accent1"/>
-          </a:effectRef>
-          <a:fontRef idx="minor">
-            <a:schemeClr val="lt1"/>
-          </a:fontRef>
-        </p:style>
-        <p:txBody>
-          <a:bodyPr rtlCol="0" anchor="ctr"/>
-          <a:lstStyle/>
-          <a:p>
-            <a:pPr algn="ctr"/>
-          </a:p>
-        </p:txBody>
-      </p:sp>
-      <p:sp>
-        <p:nvSpPr>
-          <p:cNvPr id="4" name="Rectangle 3"/>
-          <p:cNvSpPr/>
-          <p:nvPr/>
-        </p:nvSpPr>
-        <p:spPr>
-          <a:xfrm>
-            <a:off x="0" y="0"/>
-            <a:ext cx="274320" cy="6858000"/>
-          </a:xfrm>
-          <a:prstGeom prst="rect">
-            <a:avLst/>
-          </a:prstGeom>
-          <a:solidFill>
-            <a:srgbClr val="DC756A"/>
-          </a:solidFill>
-          <a:ln>
-            <a:noFill/>
-          </a:ln>
-          <a:effectLst/>
-        </p:spPr>
-        <p:style>
-          <a:lnRef idx="1">
-            <a:schemeClr val="accent1"/>
-          </a:lnRef>
-          <a:fillRef idx="3">
-            <a:schemeClr val="accent1"/>
-          </a:fillRef>
-          <a:effectRef idx="2">
-            <a:schemeClr val="accent1"/>
-          </a:effectRef>
-          <a:fontRef idx="minor">
-            <a:schemeClr val="lt1"/>
-          </a:fontRef>
-        </p:style>
-        <p:txBody>
-          <a:bodyPr rtlCol="0" anchor="ctr"/>
-          <a:lstStyle/>
-          <a:p>
-            <a:pPr algn="ctr"/>
-          </a:p>
-        </p:txBody>
-      </p:sp>
-      <p:sp>
-        <p:nvSpPr>
-          <p:cNvPr id="5" name="TextBox 4"/>
-          <p:cNvSpPr txBox="1"/>
-          <p:nvPr/>
-        </p:nvSpPr>
-        <p:spPr>
-          <a:xfrm>
-            <a:off x="1280160" y="2377440"/>
-            <a:ext cx="9692640" cy="411480"/>
-          </a:xfrm>
-          <a:prstGeom prst="rect">
-            <a:avLst/>
-          </a:prstGeom>
-          <a:noFill/>
-        </p:spPr>
-        <p:txBody>
-          <a:bodyPr wrap="none">
-            <a:spAutoFit/>
-          </a:bodyPr>
-          <a:lstStyle/>
-          <a:p>
-            <a:r>
-              <a:rPr sz="1500" b="1">
-                <a:solidFill>
-                  <a:srgbClr val="DC756A"/>
-                </a:solidFill>
-                <a:latin typeface="Calibri"/>
-              </a:rPr>
-              <a:t>MỤC 1.4 – 1.5</a:t>
-            </a:r>
-          </a:p>
-        </p:txBody>
-      </p:sp>
-      <p:sp>
-        <p:nvSpPr>
-          <p:cNvPr id="6" name="TextBox 5"/>
-          <p:cNvSpPr txBox="1"/>
-          <p:nvPr/>
-        </p:nvSpPr>
-        <p:spPr>
-          <a:xfrm>
-            <a:off x="1280160" y="2788920"/>
-            <a:ext cx="9601200" cy="1371600"/>
-          </a:xfrm>
-          <a:prstGeom prst="rect">
-            <a:avLst/>
-          </a:prstGeom>
-          <a:noFill/>
-        </p:spPr>
-        <p:txBody>
-          <a:bodyPr wrap="square">
-            <a:spAutoFit/>
-          </a:bodyPr>
-          <a:lstStyle/>
-          <a:p>
-            <a:r>
-              <a:rPr sz="3800" b="1">
-                <a:solidFill>
-                  <a:srgbClr val="AC4D33"/>
-                </a:solidFill>
-                <a:latin typeface="Cambria"/>
-              </a:rPr>
-              <a:t>Yếu tố ảnh hưởng và nguyên tắc</a:t>
-            </a:r>
-          </a:p>
-        </p:txBody>
-      </p:sp>
-      <p:sp>
-        <p:nvSpPr>
-          <p:cNvPr id="7" name="TextBox 6"/>
-          <p:cNvSpPr txBox="1"/>
-          <p:nvPr/>
-        </p:nvSpPr>
-        <p:spPr>
-          <a:xfrm>
-            <a:off x="1280160" y="4224528"/>
-            <a:ext cx="9418320" cy="640080"/>
-          </a:xfrm>
-          <a:prstGeom prst="rect">
-            <a:avLst/>
-          </a:prstGeom>
-          <a:noFill/>
-        </p:spPr>
-        <p:txBody>
-          <a:bodyPr wrap="square">
-            <a:spAutoFit/>
-          </a:bodyPr>
-          <a:lstStyle/>
-          <a:p>
-            <a:r>
-              <a:rPr sz="1450" i="1">
-                <a:solidFill>
-                  <a:srgbClr val="8A7A76"/>
-                </a:solidFill>
-                <a:latin typeface="Calibri"/>
-              </a:rPr>
-              <a:t>Điều gì làm hỏng một cuộc giao tiếp, và năm nguyên tắc giúp ta tránh được điều đó.</a:t>
-            </a:r>
-          </a:p>
-        </p:txBody>
-      </p:sp>
-      <p:sp>
-        <p:nvSpPr>
-          <p:cNvPr id="8" name="TextBox 7"/>
-          <p:cNvSpPr txBox="1"/>
-          <p:nvPr/>
-        </p:nvSpPr>
-        <p:spPr>
-          <a:xfrm>
-            <a:off x="502920" y="6419088"/>
-            <a:ext cx="7772400" cy="292608"/>
-          </a:xfrm>
-          <a:prstGeom prst="rect">
-            <a:avLst/>
-          </a:prstGeom>
-          <a:noFill/>
-        </p:spPr>
-        <p:txBody>
-          <a:bodyPr wrap="none">
-            <a:spAutoFit/>
-          </a:bodyPr>
-          <a:lstStyle/>
-          <a:p>
-            <a:r>
-              <a:rPr sz="900">
-                <a:solidFill>
-                  <a:srgbClr val="8A7A76"/>
-                </a:solidFill>
-                <a:latin typeface="Calibri"/>
-              </a:rPr>
-              <a:t>Je m'appelle Huong  •  GV. Đỗ Thùy Hương  •  EC1103</a:t>
-            </a:r>
-          </a:p>
-        </p:txBody>
-      </p:sp>
-      <p:sp>
-        <p:nvSpPr>
-          <p:cNvPr id="9" name="TextBox 8"/>
-          <p:cNvSpPr txBox="1"/>
-          <p:nvPr/>
-        </p:nvSpPr>
-        <p:spPr>
-          <a:xfrm>
-            <a:off x="9326880" y="6419088"/>
-            <a:ext cx="1920240" cy="292608"/>
-          </a:xfrm>
-          <a:prstGeom prst="rect">
-            <a:avLst/>
-          </a:prstGeom>
-          <a:noFill/>
-        </p:spPr>
-        <p:txBody>
-          <a:bodyPr wrap="none">
-            <a:spAutoFit/>
-          </a:bodyPr>
-          <a:lstStyle/>
-          <a:p>
-            <a:pPr algn="r"/>
-            <a:r>
-              <a:rPr sz="900">
-                <a:solidFill>
-                  <a:srgbClr val="8A7A76"/>
-                </a:solidFill>
-                <a:latin typeface="Calibri"/>
-              </a:rPr>
-              <a:t>Chương 1</a:t>
-            </a:r>
           </a:p>
         </p:txBody>
       </p:sp>
@@ -10694,6 +11269,327 @@
 </file>
 
 <file path=ppt/slides/slide5.xml><?xml version="1.0" encoding="utf-8"?>
+<p:sld xmlns:a="http://schemas.openxmlformats.org/drawingml/2006/main" xmlns:p="http://schemas.openxmlformats.org/presentationml/2006/main" xmlns:r="http://schemas.openxmlformats.org/officeDocument/2006/relationships">
+  <p:cSld>
+    <p:spTree>
+      <p:nvGrpSpPr>
+        <p:cNvPr id="1" name=""/>
+        <p:cNvGrpSpPr/>
+        <p:nvPr/>
+      </p:nvGrpSpPr>
+      <p:grpSpPr/>
+      <p:sp>
+        <p:nvSpPr>
+          <p:cNvPr id="2" name="Rectangle 1"/>
+          <p:cNvSpPr/>
+          <p:nvPr/>
+        </p:nvSpPr>
+        <p:spPr>
+          <a:xfrm>
+            <a:off x="0" y="0"/>
+            <a:ext cx="12191695" cy="6858000"/>
+          </a:xfrm>
+          <a:prstGeom prst="rect">
+            <a:avLst/>
+          </a:prstGeom>
+          <a:solidFill>
+            <a:srgbClr val="FDFBF8"/>
+          </a:solidFill>
+          <a:ln>
+            <a:noFill/>
+          </a:ln>
+          <a:effectLst/>
+        </p:spPr>
+        <p:style>
+          <a:lnRef idx="1">
+            <a:schemeClr val="accent1"/>
+          </a:lnRef>
+          <a:fillRef idx="3">
+            <a:schemeClr val="accent1"/>
+          </a:fillRef>
+          <a:effectRef idx="2">
+            <a:schemeClr val="accent1"/>
+          </a:effectRef>
+          <a:fontRef idx="minor">
+            <a:schemeClr val="lt1"/>
+          </a:fontRef>
+        </p:style>
+        <p:txBody>
+          <a:bodyPr rtlCol="0" anchor="ctr"/>
+          <a:lstStyle/>
+          <a:p>
+            <a:pPr algn="ctr"/>
+          </a:p>
+        </p:txBody>
+      </p:sp>
+      <p:sp>
+        <p:nvSpPr>
+          <p:cNvPr id="3" name="Rectangle 2"/>
+          <p:cNvSpPr/>
+          <p:nvPr/>
+        </p:nvSpPr>
+        <p:spPr>
+          <a:xfrm>
+            <a:off x="0" y="2103120"/>
+            <a:ext cx="12191695" cy="2743200"/>
+          </a:xfrm>
+          <a:prstGeom prst="rect">
+            <a:avLst/>
+          </a:prstGeom>
+          <a:solidFill>
+            <a:srgbClr val="FDF1EF"/>
+          </a:solidFill>
+          <a:ln>
+            <a:noFill/>
+          </a:ln>
+          <a:effectLst/>
+        </p:spPr>
+        <p:style>
+          <a:lnRef idx="1">
+            <a:schemeClr val="accent1"/>
+          </a:lnRef>
+          <a:fillRef idx="3">
+            <a:schemeClr val="accent1"/>
+          </a:fillRef>
+          <a:effectRef idx="2">
+            <a:schemeClr val="accent1"/>
+          </a:effectRef>
+          <a:fontRef idx="minor">
+            <a:schemeClr val="lt1"/>
+          </a:fontRef>
+        </p:style>
+        <p:txBody>
+          <a:bodyPr rtlCol="0" anchor="ctr"/>
+          <a:lstStyle/>
+          <a:p>
+            <a:pPr algn="ctr"/>
+          </a:p>
+        </p:txBody>
+      </p:sp>
+      <p:sp>
+        <p:nvSpPr>
+          <p:cNvPr id="4" name="Rectangle 3"/>
+          <p:cNvSpPr/>
+          <p:nvPr/>
+        </p:nvSpPr>
+        <p:spPr>
+          <a:xfrm>
+            <a:off x="0" y="0"/>
+            <a:ext cx="274320" cy="6858000"/>
+          </a:xfrm>
+          <a:prstGeom prst="rect">
+            <a:avLst/>
+          </a:prstGeom>
+          <a:solidFill>
+            <a:srgbClr val="DC756A"/>
+          </a:solidFill>
+          <a:ln>
+            <a:noFill/>
+          </a:ln>
+          <a:effectLst/>
+        </p:spPr>
+        <p:style>
+          <a:lnRef idx="1">
+            <a:schemeClr val="accent1"/>
+          </a:lnRef>
+          <a:fillRef idx="3">
+            <a:schemeClr val="accent1"/>
+          </a:fillRef>
+          <a:effectRef idx="2">
+            <a:schemeClr val="accent1"/>
+          </a:effectRef>
+          <a:fontRef idx="minor">
+            <a:schemeClr val="lt1"/>
+          </a:fontRef>
+        </p:style>
+        <p:txBody>
+          <a:bodyPr rtlCol="0" anchor="ctr"/>
+          <a:lstStyle/>
+          <a:p>
+            <a:pPr algn="ctr"/>
+          </a:p>
+        </p:txBody>
+      </p:sp>
+      <p:sp>
+        <p:nvSpPr>
+          <p:cNvPr id="5" name="TextBox 4"/>
+          <p:cNvSpPr txBox="1"/>
+          <p:nvPr/>
+        </p:nvSpPr>
+        <p:spPr>
+          <a:xfrm>
+            <a:off x="1280160" y="2377440"/>
+            <a:ext cx="9692640" cy="411480"/>
+          </a:xfrm>
+          <a:prstGeom prst="rect">
+            <a:avLst/>
+          </a:prstGeom>
+          <a:noFill/>
+        </p:spPr>
+        <p:txBody>
+          <a:bodyPr wrap="none">
+            <a:spAutoFit/>
+          </a:bodyPr>
+          <a:lstStyle/>
+          <a:p>
+            <a:r>
+              <a:rPr sz="1500" b="1">
+                <a:solidFill>
+                  <a:srgbClr val="DC756A"/>
+                </a:solidFill>
+                <a:latin typeface="Calibri"/>
+              </a:rPr>
+              <a:t>MỤC 1.1 – 1.2</a:t>
+            </a:r>
+          </a:p>
+        </p:txBody>
+      </p:sp>
+      <p:sp>
+        <p:nvSpPr>
+          <p:cNvPr id="6" name="TextBox 5"/>
+          <p:cNvSpPr txBox="1"/>
+          <p:nvPr/>
+        </p:nvSpPr>
+        <p:spPr>
+          <a:xfrm>
+            <a:off x="1280160" y="2788920"/>
+            <a:ext cx="9601200" cy="1371600"/>
+          </a:xfrm>
+          <a:prstGeom prst="rect">
+            <a:avLst/>
+          </a:prstGeom>
+          <a:noFill/>
+        </p:spPr>
+        <p:txBody>
+          <a:bodyPr wrap="square">
+            <a:spAutoFit/>
+          </a:bodyPr>
+          <a:lstStyle/>
+          <a:p>
+            <a:r>
+              <a:rPr sz="3800" b="1">
+                <a:solidFill>
+                  <a:srgbClr val="AC4D33"/>
+                </a:solidFill>
+                <a:latin typeface="Cambria"/>
+              </a:rPr>
+              <a:t>Bản chất và phương tiện giao tiếp</a:t>
+            </a:r>
+          </a:p>
+        </p:txBody>
+      </p:sp>
+      <p:sp>
+        <p:nvSpPr>
+          <p:cNvPr id="7" name="TextBox 6"/>
+          <p:cNvSpPr txBox="1"/>
+          <p:nvPr/>
+        </p:nvSpPr>
+        <p:spPr>
+          <a:xfrm>
+            <a:off x="1280160" y="4224528"/>
+            <a:ext cx="9418320" cy="640080"/>
+          </a:xfrm>
+          <a:prstGeom prst="rect">
+            <a:avLst/>
+          </a:prstGeom>
+          <a:noFill/>
+        </p:spPr>
+        <p:txBody>
+          <a:bodyPr wrap="square">
+            <a:spAutoFit/>
+          </a:bodyPr>
+          <a:lstStyle/>
+          <a:p>
+            <a:r>
+              <a:rPr sz="1450" i="1">
+                <a:solidFill>
+                  <a:srgbClr val="8A7A76"/>
+                </a:solidFill>
+                <a:latin typeface="Calibri"/>
+              </a:rPr>
+              <a:t>Hiểu đúng bản chất trước khi luyện kỹ năng: giao tiếp là gì, diễn ra qua những khâu nào, bằng phương tiện gì.</a:t>
+            </a:r>
+          </a:p>
+        </p:txBody>
+      </p:sp>
+      <p:sp>
+        <p:nvSpPr>
+          <p:cNvPr id="8" name="TextBox 7"/>
+          <p:cNvSpPr txBox="1"/>
+          <p:nvPr/>
+        </p:nvSpPr>
+        <p:spPr>
+          <a:xfrm>
+            <a:off x="502920" y="6419088"/>
+            <a:ext cx="7772400" cy="292608"/>
+          </a:xfrm>
+          <a:prstGeom prst="rect">
+            <a:avLst/>
+          </a:prstGeom>
+          <a:noFill/>
+        </p:spPr>
+        <p:txBody>
+          <a:bodyPr wrap="none">
+            <a:spAutoFit/>
+          </a:bodyPr>
+          <a:lstStyle/>
+          <a:p>
+            <a:r>
+              <a:rPr sz="900">
+                <a:solidFill>
+                  <a:srgbClr val="8A7A76"/>
+                </a:solidFill>
+                <a:latin typeface="Calibri"/>
+              </a:rPr>
+              <a:t>Je m'appelle Huong  •  GV. Đỗ Thùy Hương  •  EC1103</a:t>
+            </a:r>
+          </a:p>
+        </p:txBody>
+      </p:sp>
+      <p:sp>
+        <p:nvSpPr>
+          <p:cNvPr id="9" name="TextBox 8"/>
+          <p:cNvSpPr txBox="1"/>
+          <p:nvPr/>
+        </p:nvSpPr>
+        <p:spPr>
+          <a:xfrm>
+            <a:off x="9326880" y="6419088"/>
+            <a:ext cx="1920240" cy="292608"/>
+          </a:xfrm>
+          <a:prstGeom prst="rect">
+            <a:avLst/>
+          </a:prstGeom>
+          <a:noFill/>
+        </p:spPr>
+        <p:txBody>
+          <a:bodyPr wrap="none">
+            <a:spAutoFit/>
+          </a:bodyPr>
+          <a:lstStyle/>
+          <a:p>
+            <a:pPr algn="r"/>
+            <a:r>
+              <a:rPr sz="900">
+                <a:solidFill>
+                  <a:srgbClr val="8A7A76"/>
+                </a:solidFill>
+                <a:latin typeface="Calibri"/>
+              </a:rPr>
+              <a:t>Chương 1</a:t>
+            </a:r>
+          </a:p>
+        </p:txBody>
+      </p:sp>
+    </p:spTree>
+  </p:cSld>
+  <p:clrMapOvr>
+    <a:masterClrMapping/>
+  </p:clrMapOvr>
+</p:sld>
+</file>
+
+<file path=ppt/slides/slide6.xml><?xml version="1.0" encoding="utf-8"?>
 <p:sld xmlns:a="http://schemas.openxmlformats.org/drawingml/2006/main" xmlns:r="http://schemas.openxmlformats.org/officeDocument/2006/relationships" xmlns:p="http://schemas.openxmlformats.org/presentationml/2006/main">
   <p:cSld name="Slide 5">
     <p:bg>
@@ -11229,7 +12125,7 @@
 </p:sld>
 </file>
 
-<file path=ppt/slides/slide6.xml><?xml version="1.0" encoding="utf-8"?>
+<file path=ppt/slides/slide7.xml><?xml version="1.0" encoding="utf-8"?>
 <p:sld xmlns:a="http://schemas.openxmlformats.org/drawingml/2006/main" xmlns:r="http://schemas.openxmlformats.org/officeDocument/2006/relationships" xmlns:p="http://schemas.openxmlformats.org/presentationml/2006/main">
   <p:cSld name="Slide 6">
     <p:bg>
@@ -11852,7 +12748,7 @@
 </p:sld>
 </file>
 
-<file path=ppt/slides/slide7.xml><?xml version="1.0" encoding="utf-8"?>
+<file path=ppt/slides/slide8.xml><?xml version="1.0" encoding="utf-8"?>
 <p:sld xmlns:a="http://schemas.openxmlformats.org/drawingml/2006/main" xmlns:r="http://schemas.openxmlformats.org/officeDocument/2006/relationships" xmlns:p="http://schemas.openxmlformats.org/presentationml/2006/main">
   <p:cSld name="Slide 7">
     <p:bg>
@@ -12186,7 +13082,7 @@
 </p:sld>
 </file>
 
-<file path=ppt/slides/slide8.xml><?xml version="1.0" encoding="utf-8"?>
+<file path=ppt/slides/slide9.xml><?xml version="1.0" encoding="utf-8"?>
 <p:sld xmlns:a="http://schemas.openxmlformats.org/drawingml/2006/main" xmlns:r="http://schemas.openxmlformats.org/officeDocument/2006/relationships" xmlns:p="http://schemas.openxmlformats.org/presentationml/2006/main">
   <p:cSld name="Slide 8">
     <p:bg>
@@ -12711,902 +13607,6 @@
               <a:t>Rõ  •  lịch sự  •  tích cực  •  ngắn gọn</a:t>
             </a:r>
             <a:endParaRPr lang="en-US" sz="2000" dirty="0"/>
-          </a:p>
-        </p:txBody>
-      </p:sp>
-    </p:spTree>
-  </p:cSld>
-  <p:clrMapOvr>
-    <a:masterClrMapping/>
-  </p:clrMapOvr>
-</p:sld>
-</file>
-
-<file path=ppt/slides/slide9.xml><?xml version="1.0" encoding="utf-8"?>
-<p:sld xmlns:a="http://schemas.openxmlformats.org/drawingml/2006/main" xmlns:r="http://schemas.openxmlformats.org/officeDocument/2006/relationships" xmlns:p="http://schemas.openxmlformats.org/presentationml/2006/main">
-  <p:cSld name="Slide 9">
-    <p:bg>
-      <p:bgPr>
-        <a:solidFill>
-          <a:srgbClr val="FDFBF8"/>
-        </a:solidFill>
-      </p:bgPr>
-    </p:bg>
-    <p:spTree>
-      <p:nvGrpSpPr>
-        <p:cNvPr id="1" name=""/>
-        <p:cNvGrpSpPr/>
-        <p:nvPr/>
-      </p:nvGrpSpPr>
-      <p:grpSpPr>
-        <a:xfrm>
-          <a:off x="0" y="0"/>
-          <a:ext cx="0" cy="0"/>
-          <a:chOff x="0" y="0"/>
-          <a:chExt cx="0" cy="0"/>
-        </a:xfrm>
-      </p:grpSpPr>
-      <p:pic>
-        <p:nvPicPr>
-          <p:cNvPr id="2" name="Image 0" descr="assets/logo_tron.png">    </p:cNvPr>
-          <p:cNvPicPr>
-            <a:picLocks noChangeAspect="1"/>
-          </p:cNvPicPr>
-          <p:nvPr/>
-        </p:nvPicPr>
-        <p:blipFill>
-          <a:blip r:embed="rId1"/>
-          <a:stretch>
-            <a:fillRect/>
-          </a:stretch>
-        </p:blipFill>
-        <p:spPr>
-          <a:xfrm>
-            <a:off x="411480" y="6327648"/>
-            <a:ext cx="384048" cy="384048"/>
-          </a:xfrm>
-          <a:prstGeom prst="rect">
-            <a:avLst/>
-          </a:prstGeom>
-        </p:spPr>
-      </p:pic>
-      <p:sp>
-        <p:nvSpPr>
-          <p:cNvPr id="3" name="Text 0"/>
-          <p:cNvSpPr/>
-          <p:nvPr/>
-        </p:nvSpPr>
-        <p:spPr>
-          <a:xfrm>
-            <a:off x="868680" y="6355080"/>
-            <a:ext cx="7498080" cy="310896"/>
-          </a:xfrm>
-          <a:prstGeom prst="rect">
-            <a:avLst/>
-          </a:prstGeom>
-          <a:noFill/>
-          <a:ln/>
-        </p:spPr>
-        <p:txBody>
-          <a:bodyPr wrap="square" lIns="0" tIns="0" rIns="0" bIns="0" rtlCol="0" anchor="ctr"/>
-          <a:lstStyle/>
-          <a:p>
-            <a:pPr indent="0" marL="0">
-              <a:buNone/>
-            </a:pPr>
-            <a:r>
-              <a:rPr lang="en-US" sz="900" dirty="0">
-                <a:solidFill>
-                  <a:srgbClr val="8A7A76"/>
-                </a:solidFill>
-                <a:latin typeface="Calibri" pitchFamily="34" charset="0"/>
-                <a:ea typeface="Calibri" pitchFamily="34" charset="-122"/>
-                <a:cs typeface="Calibri" pitchFamily="34" charset="-120"/>
-              </a:rPr>
-              <a:t>Je m'appelle Huong  •  GV. Đỗ Thùy Hương  •  EC1103</a:t>
-            </a:r>
-            <a:endParaRPr lang="en-US" sz="900" dirty="0"/>
-          </a:p>
-        </p:txBody>
-      </p:sp>
-      <p:sp>
-        <p:nvSpPr>
-          <p:cNvPr id="4" name="Text 1"/>
-          <p:cNvSpPr/>
-          <p:nvPr/>
-        </p:nvSpPr>
-        <p:spPr>
-          <a:xfrm>
-            <a:off x="8503920" y="6355080"/>
-            <a:ext cx="2743200" cy="310896"/>
-          </a:xfrm>
-          <a:prstGeom prst="rect">
-            <a:avLst/>
-          </a:prstGeom>
-          <a:noFill/>
-          <a:ln/>
-        </p:spPr>
-        <p:txBody>
-          <a:bodyPr wrap="square" lIns="0" tIns="0" rIns="0" bIns="0" rtlCol="0" anchor="ctr"/>
-          <a:lstStyle/>
-          <a:p>
-            <a:pPr algn="r" indent="0" marL="0">
-              <a:buNone/>
-            </a:pPr>
-            <a:r>
-              <a:rPr lang="en-US" sz="900" dirty="0">
-                <a:solidFill>
-                  <a:srgbClr val="8A7A76"/>
-                </a:solidFill>
-                <a:latin typeface="Calibri" pitchFamily="34" charset="0"/>
-                <a:ea typeface="Calibri" pitchFamily="34" charset="-122"/>
-                <a:cs typeface="Calibri" pitchFamily="34" charset="-120"/>
-              </a:rPr>
-              <a:t>Chương 1</a:t>
-            </a:r>
-            <a:endParaRPr lang="en-US" sz="900" dirty="0"/>
-          </a:p>
-        </p:txBody>
-      </p:sp>
-      <p:sp>
-        <p:nvSpPr>
-          <p:cNvPr id="5" name="Shape 2"/>
-          <p:cNvSpPr/>
-          <p:nvPr/>
-        </p:nvSpPr>
-        <p:spPr>
-          <a:xfrm>
-            <a:off x="11430000" y="6327648"/>
-            <a:ext cx="365760" cy="365760"/>
-          </a:xfrm>
-          <a:prstGeom prst="ellipse">
-            <a:avLst/>
-          </a:prstGeom>
-          <a:solidFill>
-            <a:srgbClr val="DC756A"/>
-          </a:solidFill>
-          <a:ln/>
-        </p:spPr>
-        <p:txBody>
-          <a:bodyPr/>
-          <a:p/>
-        </p:txBody>
-      </p:sp>
-      <p:sp>
-        <p:nvSpPr>
-          <p:cNvPr id="6" name="Text 3"/>
-          <p:cNvSpPr/>
-          <p:nvPr/>
-        </p:nvSpPr>
-        <p:spPr>
-          <a:xfrm>
-            <a:off x="11430000" y="6327648"/>
-            <a:ext cx="365760" cy="365760"/>
-          </a:xfrm>
-          <a:prstGeom prst="rect">
-            <a:avLst/>
-          </a:prstGeom>
-          <a:noFill/>
-          <a:ln/>
-        </p:spPr>
-        <p:txBody>
-          <a:bodyPr wrap="square" lIns="0" tIns="0" rIns="0" bIns="0" rtlCol="0" anchor="ctr"/>
-          <a:lstStyle/>
-          <a:p>
-            <a:pPr algn="ctr" indent="0" marL="0">
-              <a:buNone/>
-            </a:pPr>
-            <a:r>
-              <a:rPr lang="en-US" sz="1000" b="1" dirty="0">
-                <a:solidFill>
-                  <a:srgbClr val="FFFFFF"/>
-                </a:solidFill>
-                <a:latin typeface="Calibri" pitchFamily="34" charset="0"/>
-                <a:ea typeface="Calibri" pitchFamily="34" charset="-122"/>
-                <a:cs typeface="Calibri" pitchFamily="34" charset="-120"/>
-              </a:rPr>
-              <a:t>9</a:t>
-            </a:r>
-            <a:endParaRPr lang="en-US" sz="1000" dirty="0"/>
-          </a:p>
-        </p:txBody>
-      </p:sp>
-      <p:sp>
-        <p:nvSpPr>
-          <p:cNvPr id="7" name="Text 4"/>
-          <p:cNvSpPr/>
-          <p:nvPr/>
-        </p:nvSpPr>
-        <p:spPr>
-          <a:xfrm>
-            <a:off x="502920" y="310896"/>
-            <a:ext cx="11155680" cy="274320"/>
-          </a:xfrm>
-          <a:prstGeom prst="rect">
-            <a:avLst/>
-          </a:prstGeom>
-          <a:noFill/>
-          <a:ln/>
-        </p:spPr>
-        <p:txBody>
-          <a:bodyPr wrap="square" lIns="0" tIns="0" rIns="0" bIns="0" rtlCol="0" anchor="ctr"/>
-          <a:lstStyle/>
-          <a:p>
-            <a:pPr indent="0" marL="0">
-              <a:buNone/>
-            </a:pPr>
-            <a:r>
-              <a:rPr lang="en-US" sz="1100" b="1" spc="300" kern="0" dirty="0">
-                <a:solidFill>
-                  <a:srgbClr val="DC756A"/>
-                </a:solidFill>
-                <a:latin typeface="Calibri" pitchFamily="34" charset="0"/>
-                <a:ea typeface="Calibri" pitchFamily="34" charset="-122"/>
-                <a:cs typeface="Calibri" pitchFamily="34" charset="-120"/>
-              </a:rPr>
-              <a:t>1.2</a:t>
-            </a:r>
-            <a:endParaRPr lang="en-US" sz="1100" dirty="0"/>
-          </a:p>
-        </p:txBody>
-      </p:sp>
-      <p:sp>
-        <p:nvSpPr>
-          <p:cNvPr id="8" name="Text 5"/>
-          <p:cNvSpPr/>
-          <p:nvPr/>
-        </p:nvSpPr>
-        <p:spPr>
-          <a:xfrm>
-            <a:off x="502920" y="576072"/>
-            <a:ext cx="11155680" cy="713232"/>
-          </a:xfrm>
-          <a:prstGeom prst="rect">
-            <a:avLst/>
-          </a:prstGeom>
-          <a:noFill/>
-          <a:ln/>
-        </p:spPr>
-        <p:txBody>
-          <a:bodyPr wrap="square" lIns="0" tIns="0" rIns="0" bIns="0" rtlCol="0" anchor="ctr"/>
-          <a:lstStyle/>
-          <a:p>
-            <a:pPr indent="0" marL="0">
-              <a:buNone/>
-            </a:pPr>
-            <a:r>
-              <a:rPr lang="en-US" sz="2700" b="1" dirty="0">
-                <a:solidFill>
-                  <a:srgbClr val="AC4D33"/>
-                </a:solidFill>
-                <a:latin typeface="Cambria" pitchFamily="34" charset="0"/>
-                <a:ea typeface="Cambria" pitchFamily="34" charset="-122"/>
-                <a:cs typeface="Cambria" pitchFamily="34" charset="-120"/>
-              </a:rPr>
-              <a:t>Phương tiện giao tiếp: phi ngôn ngữ</a:t>
-            </a:r>
-            <a:endParaRPr lang="en-US" sz="2700" dirty="0"/>
-          </a:p>
-        </p:txBody>
-      </p:sp>
-      <p:sp>
-        <p:nvSpPr>
-          <p:cNvPr id="9" name="Shape 6"/>
-          <p:cNvSpPr/>
-          <p:nvPr/>
-        </p:nvSpPr>
-        <p:spPr>
-          <a:xfrm>
-            <a:off x="502920" y="1600200"/>
-            <a:ext cx="5509260" cy="1280160"/>
-          </a:xfrm>
-          <a:prstGeom prst="roundRect">
-            <a:avLst>
-              <a:gd name="adj" fmla="val 6429"/>
-            </a:avLst>
-          </a:prstGeom>
-          <a:solidFill>
-            <a:srgbClr val="FDF1EF"/>
-          </a:solidFill>
-          <a:ln w="15875">
-            <a:solidFill>
-              <a:srgbClr val="FBCEC9"/>
-            </a:solidFill>
-            <a:prstDash val="solid"/>
-          </a:ln>
-        </p:spPr>
-        <p:txBody>
-          <a:bodyPr/>
-          <a:p/>
-        </p:txBody>
-      </p:sp>
-      <p:sp>
-        <p:nvSpPr>
-          <p:cNvPr id="10" name="Text 7"/>
-          <p:cNvSpPr/>
-          <p:nvPr/>
-        </p:nvSpPr>
-        <p:spPr>
-          <a:xfrm>
-            <a:off x="722376" y="1673352"/>
-            <a:ext cx="5070348" cy="1133856"/>
-          </a:xfrm>
-          <a:prstGeom prst="rect">
-            <a:avLst/>
-          </a:prstGeom>
-          <a:noFill/>
-          <a:ln/>
-        </p:spPr>
-        <p:txBody>
-          <a:bodyPr wrap="square" lIns="0" tIns="0" rIns="0" bIns="0" rtlCol="0" anchor="ctr"/>
-          <a:lstStyle/>
-          <a:p>
-            <a:pPr indent="0" marL="0">
-              <a:buNone/>
-            </a:pPr>
-            <a:r>
-              <a:rPr lang="en-US" sz="1700" b="1" dirty="0">
-                <a:solidFill>
-                  <a:srgbClr val="AC4D33"/>
-                </a:solidFill>
-                <a:latin typeface="Calibri" pitchFamily="34" charset="0"/>
-                <a:ea typeface="Calibri" pitchFamily="34" charset="-122"/>
-                <a:cs typeface="Calibri" pitchFamily="34" charset="-120"/>
-              </a:rPr>
-              <a:t>Ánh mắt – nét mặt</a:t>
-            </a:r>
-            <a:endParaRPr lang="en-US" sz="1700" dirty="0"/>
-          </a:p>
-          <a:p>
-            <a:pPr indent="0" marL="0">
-              <a:buNone/>
-            </a:pPr>
-            <a:r>
-              <a:rPr lang="en-US" sz="1400" dirty="0">
-                <a:solidFill>
-                  <a:srgbClr val="3A2B28"/>
-                </a:solidFill>
-                <a:latin typeface="Calibri" pitchFamily="34" charset="0"/>
-                <a:ea typeface="Calibri" pitchFamily="34" charset="-122"/>
-                <a:cs typeface="Calibri" pitchFamily="34" charset="-120"/>
-              </a:rPr>
-              <a:t>Kênh biểu cảm mạnh nhất</a:t>
-            </a:r>
-            <a:endParaRPr lang="en-US" sz="1700" dirty="0"/>
-          </a:p>
-        </p:txBody>
-      </p:sp>
-      <p:sp>
-        <p:nvSpPr>
-          <p:cNvPr id="11" name="Shape 8"/>
-          <p:cNvSpPr/>
-          <p:nvPr/>
-        </p:nvSpPr>
-        <p:spPr>
-          <a:xfrm>
-            <a:off x="6195060" y="1600200"/>
-            <a:ext cx="5509260" cy="1280160"/>
-          </a:xfrm>
-          <a:prstGeom prst="roundRect">
-            <a:avLst>
-              <a:gd name="adj" fmla="val 6429"/>
-            </a:avLst>
-          </a:prstGeom>
-          <a:solidFill>
-            <a:srgbClr val="FDF1EF"/>
-          </a:solidFill>
-          <a:ln w="15875">
-            <a:solidFill>
-              <a:srgbClr val="FBCEC9"/>
-            </a:solidFill>
-            <a:prstDash val="solid"/>
-          </a:ln>
-        </p:spPr>
-        <p:txBody>
-          <a:bodyPr/>
-          <a:p/>
-        </p:txBody>
-      </p:sp>
-      <p:sp>
-        <p:nvSpPr>
-          <p:cNvPr id="12" name="Text 9"/>
-          <p:cNvSpPr/>
-          <p:nvPr/>
-        </p:nvSpPr>
-        <p:spPr>
-          <a:xfrm>
-            <a:off x="6414516" y="1673352"/>
-            <a:ext cx="5070348" cy="1133856"/>
-          </a:xfrm>
-          <a:prstGeom prst="rect">
-            <a:avLst/>
-          </a:prstGeom>
-          <a:noFill/>
-          <a:ln/>
-        </p:spPr>
-        <p:txBody>
-          <a:bodyPr wrap="square" lIns="0" tIns="0" rIns="0" bIns="0" rtlCol="0" anchor="ctr"/>
-          <a:lstStyle/>
-          <a:p>
-            <a:pPr indent="0" marL="0">
-              <a:buNone/>
-            </a:pPr>
-            <a:r>
-              <a:rPr lang="en-US" sz="1700" b="1" dirty="0">
-                <a:solidFill>
-                  <a:srgbClr val="AC4D33"/>
-                </a:solidFill>
-                <a:latin typeface="Calibri" pitchFamily="34" charset="0"/>
-                <a:ea typeface="Calibri" pitchFamily="34" charset="-122"/>
-                <a:cs typeface="Calibri" pitchFamily="34" charset="-120"/>
-              </a:rPr>
-              <a:t>Cử chỉ – tư thế</a:t>
-            </a:r>
-            <a:endParaRPr lang="en-US" sz="1700" dirty="0"/>
-          </a:p>
-          <a:p>
-            <a:pPr indent="0" marL="0">
-              <a:buNone/>
-            </a:pPr>
-            <a:r>
-              <a:rPr lang="en-US" sz="1400" dirty="0">
-                <a:solidFill>
-                  <a:srgbClr val="3A2B28"/>
-                </a:solidFill>
-                <a:latin typeface="Calibri" pitchFamily="34" charset="0"/>
-                <a:ea typeface="Calibri" pitchFamily="34" charset="-122"/>
-                <a:cs typeface="Calibri" pitchFamily="34" charset="-120"/>
-              </a:rPr>
-              <a:t>Thẳng và cởi mở tạo thiện cảm</a:t>
-            </a:r>
-            <a:endParaRPr lang="en-US" sz="1700" dirty="0"/>
-          </a:p>
-        </p:txBody>
-      </p:sp>
-      <p:sp>
-        <p:nvSpPr>
-          <p:cNvPr id="13" name="Shape 10"/>
-          <p:cNvSpPr/>
-          <p:nvPr/>
-        </p:nvSpPr>
-        <p:spPr>
-          <a:xfrm>
-            <a:off x="502920" y="3063240"/>
-            <a:ext cx="5509260" cy="1280160"/>
-          </a:xfrm>
-          <a:prstGeom prst="roundRect">
-            <a:avLst>
-              <a:gd name="adj" fmla="val 6429"/>
-            </a:avLst>
-          </a:prstGeom>
-          <a:solidFill>
-            <a:srgbClr val="FDF1EF"/>
-          </a:solidFill>
-          <a:ln w="15875">
-            <a:solidFill>
-              <a:srgbClr val="FBCEC9"/>
-            </a:solidFill>
-            <a:prstDash val="solid"/>
-          </a:ln>
-        </p:spPr>
-        <p:txBody>
-          <a:bodyPr/>
-          <a:p/>
-        </p:txBody>
-      </p:sp>
-      <p:sp>
-        <p:nvSpPr>
-          <p:cNvPr id="14" name="Text 11"/>
-          <p:cNvSpPr/>
-          <p:nvPr/>
-        </p:nvSpPr>
-        <p:spPr>
-          <a:xfrm>
-            <a:off x="722376" y="3136392"/>
-            <a:ext cx="5070348" cy="1133856"/>
-          </a:xfrm>
-          <a:prstGeom prst="rect">
-            <a:avLst/>
-          </a:prstGeom>
-          <a:noFill/>
-          <a:ln/>
-        </p:spPr>
-        <p:txBody>
-          <a:bodyPr wrap="square" lIns="0" tIns="0" rIns="0" bIns="0" rtlCol="0" anchor="ctr"/>
-          <a:lstStyle/>
-          <a:p>
-            <a:pPr indent="0" marL="0">
-              <a:buNone/>
-            </a:pPr>
-            <a:r>
-              <a:rPr lang="en-US" sz="1700" b="1" dirty="0">
-                <a:solidFill>
-                  <a:srgbClr val="AC4D33"/>
-                </a:solidFill>
-                <a:latin typeface="Calibri" pitchFamily="34" charset="0"/>
-                <a:ea typeface="Calibri" pitchFamily="34" charset="-122"/>
-                <a:cs typeface="Calibri" pitchFamily="34" charset="-120"/>
-              </a:rPr>
-              <a:t>Khoảng cách</a:t>
-            </a:r>
-            <a:endParaRPr lang="en-US" sz="1700" dirty="0"/>
-          </a:p>
-          <a:p>
-            <a:pPr indent="0" marL="0">
-              <a:buNone/>
-            </a:pPr>
-            <a:r>
-              <a:rPr lang="en-US" sz="1400" dirty="0">
-                <a:solidFill>
-                  <a:srgbClr val="3A2B28"/>
-                </a:solidFill>
-                <a:latin typeface="Calibri" pitchFamily="34" charset="0"/>
-                <a:ea typeface="Calibri" pitchFamily="34" charset="-122"/>
-                <a:cs typeface="Calibri" pitchFamily="34" charset="-120"/>
-              </a:rPr>
-              <a:t>Thân mật · cá nhân · xã giao · công cộng</a:t>
-            </a:r>
-            <a:endParaRPr lang="en-US" sz="1700" dirty="0"/>
-          </a:p>
-        </p:txBody>
-      </p:sp>
-      <p:sp>
-        <p:nvSpPr>
-          <p:cNvPr id="15" name="Shape 12"/>
-          <p:cNvSpPr/>
-          <p:nvPr/>
-        </p:nvSpPr>
-        <p:spPr>
-          <a:xfrm>
-            <a:off x="6195060" y="3063240"/>
-            <a:ext cx="5509260" cy="1280160"/>
-          </a:xfrm>
-          <a:prstGeom prst="roundRect">
-            <a:avLst>
-              <a:gd name="adj" fmla="val 6429"/>
-            </a:avLst>
-          </a:prstGeom>
-          <a:solidFill>
-            <a:srgbClr val="FDF1EF"/>
-          </a:solidFill>
-          <a:ln w="15875">
-            <a:solidFill>
-              <a:srgbClr val="FBCEC9"/>
-            </a:solidFill>
-            <a:prstDash val="solid"/>
-          </a:ln>
-        </p:spPr>
-        <p:txBody>
-          <a:bodyPr/>
-          <a:p/>
-        </p:txBody>
-      </p:sp>
-      <p:sp>
-        <p:nvSpPr>
-          <p:cNvPr id="16" name="Text 13"/>
-          <p:cNvSpPr/>
-          <p:nvPr/>
-        </p:nvSpPr>
-        <p:spPr>
-          <a:xfrm>
-            <a:off x="6414516" y="3136392"/>
-            <a:ext cx="5070348" cy="1133856"/>
-          </a:xfrm>
-          <a:prstGeom prst="rect">
-            <a:avLst/>
-          </a:prstGeom>
-          <a:noFill/>
-          <a:ln/>
-        </p:spPr>
-        <p:txBody>
-          <a:bodyPr wrap="square" lIns="0" tIns="0" rIns="0" bIns="0" rtlCol="0" anchor="ctr"/>
-          <a:lstStyle/>
-          <a:p>
-            <a:pPr indent="0" marL="0">
-              <a:buNone/>
-            </a:pPr>
-            <a:r>
-              <a:rPr lang="en-US" sz="1700" b="1" dirty="0">
-                <a:solidFill>
-                  <a:srgbClr val="AC4D33"/>
-                </a:solidFill>
-                <a:latin typeface="Calibri" pitchFamily="34" charset="0"/>
-                <a:ea typeface="Calibri" pitchFamily="34" charset="-122"/>
-                <a:cs typeface="Calibri" pitchFamily="34" charset="-120"/>
-              </a:rPr>
-              <a:t>Trang phục – giọng – giờ giấc</a:t>
-            </a:r>
-            <a:endParaRPr lang="en-US" sz="1700" dirty="0"/>
-          </a:p>
-          <a:p>
-            <a:pPr indent="0" marL="0">
-              <a:buNone/>
-            </a:pPr>
-            <a:r>
-              <a:rPr lang="en-US" sz="1400" dirty="0">
-                <a:solidFill>
-                  <a:srgbClr val="3A2B28"/>
-                </a:solidFill>
-                <a:latin typeface="Calibri" pitchFamily="34" charset="0"/>
-                <a:ea typeface="Calibri" pitchFamily="34" charset="-122"/>
-                <a:cs typeface="Calibri" pitchFamily="34" charset="-120"/>
-              </a:rPr>
-              <a:t>Đúng giờ cũng là một thông điệp</a:t>
-            </a:r>
-            <a:endParaRPr lang="en-US" sz="1700" dirty="0"/>
-          </a:p>
-        </p:txBody>
-      </p:sp>
-      <p:sp>
-        <p:nvSpPr>
-          <p:cNvPr id="17" name="Text 14"/>
-          <p:cNvSpPr/>
-          <p:nvPr/>
-        </p:nvSpPr>
-        <p:spPr>
-          <a:xfrm>
-            <a:off x="777240" y="4617720"/>
-            <a:ext cx="3566160" cy="868680"/>
-          </a:xfrm>
-          <a:prstGeom prst="rect">
-            <a:avLst/>
-          </a:prstGeom>
-          <a:noFill/>
-          <a:ln/>
-        </p:spPr>
-        <p:txBody>
-          <a:bodyPr wrap="square" lIns="0" tIns="0" rIns="0" bIns="0" rtlCol="0" anchor="ctr"/>
-          <a:lstStyle/>
-          <a:p>
-            <a:pPr algn="ctr" indent="0" marL="0">
-              <a:buNone/>
-            </a:pPr>
-            <a:r>
-              <a:rPr lang="en-US" sz="4400" b="1" dirty="0">
-                <a:solidFill>
-                  <a:srgbClr val="DC756A"/>
-                </a:solidFill>
-                <a:latin typeface="Cambria" pitchFamily="34" charset="0"/>
-                <a:ea typeface="Cambria" pitchFamily="34" charset="-122"/>
-                <a:cs typeface="Cambria" pitchFamily="34" charset="-120"/>
-              </a:rPr>
-              <a:t>7%</a:t>
-            </a:r>
-            <a:endParaRPr lang="en-US" sz="4400" dirty="0"/>
-          </a:p>
-        </p:txBody>
-      </p:sp>
-      <p:sp>
-        <p:nvSpPr>
-          <p:cNvPr id="18" name="Text 15"/>
-          <p:cNvSpPr/>
-          <p:nvPr/>
-        </p:nvSpPr>
-        <p:spPr>
-          <a:xfrm>
-            <a:off x="777240" y="5486400"/>
-            <a:ext cx="3566160" cy="365760"/>
-          </a:xfrm>
-          <a:prstGeom prst="rect">
-            <a:avLst/>
-          </a:prstGeom>
-          <a:noFill/>
-          <a:ln/>
-        </p:spPr>
-        <p:txBody>
-          <a:bodyPr wrap="square" lIns="0" tIns="0" rIns="0" bIns="0" rtlCol="0" anchor="ctr"/>
-          <a:lstStyle/>
-          <a:p>
-            <a:pPr algn="ctr" indent="0" marL="0">
-              <a:buNone/>
-            </a:pPr>
-            <a:r>
-              <a:rPr lang="en-US" sz="1300" b="1" spc="200" kern="0" dirty="0">
-                <a:solidFill>
-                  <a:srgbClr val="8A7A76"/>
-                </a:solidFill>
-                <a:latin typeface="Calibri" pitchFamily="34" charset="0"/>
-                <a:ea typeface="Calibri" pitchFamily="34" charset="-122"/>
-                <a:cs typeface="Calibri" pitchFamily="34" charset="-120"/>
-              </a:rPr>
-              <a:t>TỪ NGỮ</a:t>
-            </a:r>
-            <a:endParaRPr lang="en-US" sz="1300" dirty="0"/>
-          </a:p>
-        </p:txBody>
-      </p:sp>
-      <p:sp>
-        <p:nvSpPr>
-          <p:cNvPr id="19" name="Text 16"/>
-          <p:cNvSpPr/>
-          <p:nvPr/>
-        </p:nvSpPr>
-        <p:spPr>
-          <a:xfrm>
-            <a:off x="4754880" y="4617720"/>
-            <a:ext cx="3566160" cy="868680"/>
-          </a:xfrm>
-          <a:prstGeom prst="rect">
-            <a:avLst/>
-          </a:prstGeom>
-          <a:noFill/>
-          <a:ln/>
-        </p:spPr>
-        <p:txBody>
-          <a:bodyPr wrap="square" lIns="0" tIns="0" rIns="0" bIns="0" rtlCol="0" anchor="ctr"/>
-          <a:lstStyle/>
-          <a:p>
-            <a:pPr algn="ctr" indent="0" marL="0">
-              <a:buNone/>
-            </a:pPr>
-            <a:r>
-              <a:rPr lang="en-US" sz="4400" b="1" dirty="0">
-                <a:solidFill>
-                  <a:srgbClr val="DC756A"/>
-                </a:solidFill>
-                <a:latin typeface="Cambria" pitchFamily="34" charset="0"/>
-                <a:ea typeface="Cambria" pitchFamily="34" charset="-122"/>
-                <a:cs typeface="Cambria" pitchFamily="34" charset="-120"/>
-              </a:rPr>
-              <a:t>38%</a:t>
-            </a:r>
-            <a:endParaRPr lang="en-US" sz="4400" dirty="0"/>
-          </a:p>
-        </p:txBody>
-      </p:sp>
-      <p:sp>
-        <p:nvSpPr>
-          <p:cNvPr id="20" name="Text 17"/>
-          <p:cNvSpPr/>
-          <p:nvPr/>
-        </p:nvSpPr>
-        <p:spPr>
-          <a:xfrm>
-            <a:off x="4754880" y="5486400"/>
-            <a:ext cx="3566160" cy="365760"/>
-          </a:xfrm>
-          <a:prstGeom prst="rect">
-            <a:avLst/>
-          </a:prstGeom>
-          <a:noFill/>
-          <a:ln/>
-        </p:spPr>
-        <p:txBody>
-          <a:bodyPr wrap="square" lIns="0" tIns="0" rIns="0" bIns="0" rtlCol="0" anchor="ctr"/>
-          <a:lstStyle/>
-          <a:p>
-            <a:pPr algn="ctr" indent="0" marL="0">
-              <a:buNone/>
-            </a:pPr>
-            <a:r>
-              <a:rPr lang="en-US" sz="1300" b="1" spc="200" kern="0" dirty="0">
-                <a:solidFill>
-                  <a:srgbClr val="8A7A76"/>
-                </a:solidFill>
-                <a:latin typeface="Calibri" pitchFamily="34" charset="0"/>
-                <a:ea typeface="Calibri" pitchFamily="34" charset="-122"/>
-                <a:cs typeface="Calibri" pitchFamily="34" charset="-120"/>
-              </a:rPr>
-              <a:t>GIỌNG NÓI</a:t>
-            </a:r>
-            <a:endParaRPr lang="en-US" sz="1300" dirty="0"/>
-          </a:p>
-        </p:txBody>
-      </p:sp>
-      <p:sp>
-        <p:nvSpPr>
-          <p:cNvPr id="21" name="Text 18"/>
-          <p:cNvSpPr/>
-          <p:nvPr/>
-        </p:nvSpPr>
-        <p:spPr>
-          <a:xfrm>
-            <a:off x="8732520" y="4617720"/>
-            <a:ext cx="3566160" cy="868680"/>
-          </a:xfrm>
-          <a:prstGeom prst="rect">
-            <a:avLst/>
-          </a:prstGeom>
-          <a:noFill/>
-          <a:ln/>
-        </p:spPr>
-        <p:txBody>
-          <a:bodyPr wrap="square" lIns="0" tIns="0" rIns="0" bIns="0" rtlCol="0" anchor="ctr"/>
-          <a:lstStyle/>
-          <a:p>
-            <a:pPr algn="ctr" indent="0" marL="0">
-              <a:buNone/>
-            </a:pPr>
-            <a:r>
-              <a:rPr lang="en-US" sz="4400" b="1" dirty="0">
-                <a:solidFill>
-                  <a:srgbClr val="AC4D33"/>
-                </a:solidFill>
-                <a:latin typeface="Cambria" pitchFamily="34" charset="0"/>
-                <a:ea typeface="Cambria" pitchFamily="34" charset="-122"/>
-                <a:cs typeface="Cambria" pitchFamily="34" charset="-120"/>
-              </a:rPr>
-              <a:t>55%</a:t>
-            </a:r>
-            <a:endParaRPr lang="en-US" sz="4400" dirty="0"/>
-          </a:p>
-        </p:txBody>
-      </p:sp>
-      <p:sp>
-        <p:nvSpPr>
-          <p:cNvPr id="22" name="Text 19"/>
-          <p:cNvSpPr/>
-          <p:nvPr/>
-        </p:nvSpPr>
-        <p:spPr>
-          <a:xfrm>
-            <a:off x="8732520" y="5486400"/>
-            <a:ext cx="3566160" cy="365760"/>
-          </a:xfrm>
-          <a:prstGeom prst="rect">
-            <a:avLst/>
-          </a:prstGeom>
-          <a:noFill/>
-          <a:ln/>
-        </p:spPr>
-        <p:txBody>
-          <a:bodyPr wrap="square" lIns="0" tIns="0" rIns="0" bIns="0" rtlCol="0" anchor="ctr"/>
-          <a:lstStyle/>
-          <a:p>
-            <a:pPr algn="ctr" indent="0" marL="0">
-              <a:buNone/>
-            </a:pPr>
-            <a:r>
-              <a:rPr lang="en-US" sz="1300" b="1" spc="200" kern="0" dirty="0">
-                <a:solidFill>
-                  <a:srgbClr val="8A7A76"/>
-                </a:solidFill>
-                <a:latin typeface="Calibri" pitchFamily="34" charset="0"/>
-                <a:ea typeface="Calibri" pitchFamily="34" charset="-122"/>
-                <a:cs typeface="Calibri" pitchFamily="34" charset="-120"/>
-              </a:rPr>
-              <a:t>CƠ THỂ</a:t>
-            </a:r>
-            <a:endParaRPr lang="en-US" sz="1300" dirty="0"/>
-          </a:p>
-        </p:txBody>
-      </p:sp>
-      <p:sp>
-        <p:nvSpPr>
-          <p:cNvPr id="23" name="Text 20"/>
-          <p:cNvSpPr/>
-          <p:nvPr/>
-        </p:nvSpPr>
-        <p:spPr>
-          <a:xfrm>
-            <a:off x="502920" y="5943600"/>
-            <a:ext cx="11201400" cy="365760"/>
-          </a:xfrm>
-          <a:prstGeom prst="rect">
-            <a:avLst/>
-          </a:prstGeom>
-          <a:noFill/>
-          <a:ln/>
-        </p:spPr>
-        <p:txBody>
-          <a:bodyPr wrap="square" lIns="0" tIns="0" rIns="0" bIns="0" rtlCol="0" anchor="ctr"/>
-          <a:lstStyle/>
-          <a:p>
-            <a:pPr algn="ctr" indent="0" marL="0">
-              <a:buNone/>
-            </a:pPr>
-            <a:r>
-              <a:rPr lang="en-US" sz="1200" i="1" dirty="0">
-                <a:solidFill>
-                  <a:srgbClr val="8A7A76"/>
-                </a:solidFill>
-                <a:latin typeface="Calibri" pitchFamily="34" charset="0"/>
-                <a:ea typeface="Calibri" pitchFamily="34" charset="-122"/>
-                <a:cs typeface="Calibri" pitchFamily="34" charset="-120"/>
-              </a:rPr>
-              <a:t>Mehrabian — với thông điệp cảm xúc</a:t>
-            </a:r>
-            <a:endParaRPr lang="en-US" sz="1200" dirty="0"/>
           </a:p>
         </p:txBody>
       </p:sp>

</xml_diff>